<commit_message>
Move to the actual Flyport palette
The brief was the Flyport theme colour, meaning the palette from
the Flyport corporate presentation site, not the colours in the
source file. Both surfaces now use it:

  paper FBFDFE, mist F0F7F8, line DCEAED, ink 0E2830
  teal 39C0C5 / 0C7A80 / 0A5F65
  magenta EC008C / C10073, gold E9B949

His structure and his per-card assignment survive unchanged. Only
the hues move: his mint becomes mist, his deep teal becomes
teal-deep, his orange becomes gold, his rose becomes magenta. Word
count still 1840 against his 1837, and the deck stays simple, with
no shader, no animation and no photography.

Two lifted tints exist only for the dark bookend slides, where the
house gold reads 4.05:1 and the house magenta 2.4:1: gold FFD264
and magenta FFB3E0. Every text run in both files now clears AA,
and the chip glyphs clear 3:1 as graphics.
</commit_message>
<xml_diff>
--- a/Vietnam-Airlines-Bangladesh-Operations-Launch-Plan.pptx
+++ b/Vietnam-Airlines-Bangladesh-Operations-Launch-Plan.pptx
@@ -3119,7 +3119,7 @@
             <a:avLst/>
           </a:prstGeom>
           <a:solidFill>
-            <a:srgbClr val="0A4B49"/>
+            <a:srgbClr val="0A5F65"/>
           </a:solidFill>
           <a:ln>
             <a:noFill/>
@@ -3229,7 +3229,7 @@
             <a:r>
               <a:rPr sz="1050" b="0" cap="all" spc="260">
                 <a:solidFill>
-                  <a:srgbClr val="ED9D67"/>
+                  <a:srgbClr val="FFD264"/>
                 </a:solidFill>
                 <a:latin typeface="IBM Plex Mono"/>
               </a:rPr>
@@ -3280,7 +3280,7 @@
             <a:r>
               <a:rPr sz="4000" b="1">
                 <a:solidFill>
-                  <a:srgbClr val="E8823D"/>
+                  <a:srgbClr val="FFD264"/>
                 </a:solidFill>
                 <a:latin typeface="Outfit"/>
               </a:rPr>
@@ -3341,7 +3341,7 @@
             <a:r>
               <a:rPr sz="1050" b="0" i="1">
                 <a:solidFill>
-                  <a:srgbClr val="D3E8E6"/>
+                  <a:srgbClr val="DCF2F3"/>
                 </a:solidFill>
                 <a:latin typeface="Plus Jakarta Sans"/>
               </a:rPr>
@@ -3365,7 +3365,7 @@
             <a:avLst/>
           </a:prstGeom>
           <a:solidFill>
-            <a:srgbClr val="13807C"/>
+            <a:srgbClr val="0C7A80"/>
           </a:solidFill>
           <a:ln>
             <a:noFill/>
@@ -3396,7 +3396,7 @@
       </p:sp>
       <p:pic>
         <p:nvPicPr>
-          <p:cNvPr id="9" name="Picture 8" descr="his_icon1.png"/>
+          <p:cNvPr id="9" name="Picture 8" descr="fp_icon1.png"/>
           <p:cNvPicPr>
             <a:picLocks noChangeAspect="1"/>
           </p:cNvPicPr>
@@ -3451,7 +3451,7 @@
             <a:r>
               <a:rPr sz="750" b="0" cap="all" spc="130">
                 <a:solidFill>
-                  <a:srgbClr val="D3E8E6"/>
+                  <a:srgbClr val="DCF2F3"/>
                 </a:solidFill>
                 <a:latin typeface="IBM Plex Mono"/>
               </a:rPr>
@@ -3475,7 +3475,7 @@
             <a:avLst/>
           </a:prstGeom>
           <a:solidFill>
-            <a:srgbClr val="13807C"/>
+            <a:srgbClr val="0C7A80"/>
           </a:solidFill>
           <a:ln>
             <a:noFill/>
@@ -3506,7 +3506,7 @@
       </p:sp>
       <p:pic>
         <p:nvPicPr>
-          <p:cNvPr id="12" name="Picture 11" descr="his_icon2.png"/>
+          <p:cNvPr id="12" name="Picture 11" descr="fp_icon2.png"/>
           <p:cNvPicPr>
             <a:picLocks noChangeAspect="1"/>
           </p:cNvPicPr>
@@ -3561,7 +3561,7 @@
             <a:r>
               <a:rPr sz="750" b="0" cap="all" spc="130">
                 <a:solidFill>
-                  <a:srgbClr val="D3E8E6"/>
+                  <a:srgbClr val="DCF2F3"/>
                 </a:solidFill>
                 <a:latin typeface="IBM Plex Mono"/>
               </a:rPr>
@@ -3585,7 +3585,7 @@
             <a:avLst/>
           </a:prstGeom>
           <a:solidFill>
-            <a:srgbClr val="13807C"/>
+            <a:srgbClr val="0C7A80"/>
           </a:solidFill>
           <a:ln>
             <a:noFill/>
@@ -3616,7 +3616,7 @@
       </p:sp>
       <p:pic>
         <p:nvPicPr>
-          <p:cNvPr id="15" name="Picture 14" descr="his_icon3.png"/>
+          <p:cNvPr id="15" name="Picture 14" descr="fp_icon3.png"/>
           <p:cNvPicPr>
             <a:picLocks noChangeAspect="1"/>
           </p:cNvPicPr>
@@ -3671,7 +3671,7 @@
             <a:r>
               <a:rPr sz="750" b="0" cap="all" spc="130">
                 <a:solidFill>
-                  <a:srgbClr val="D3E8E6"/>
+                  <a:srgbClr val="DCF2F3"/>
                 </a:solidFill>
                 <a:latin typeface="IBM Plex Mono"/>
               </a:rPr>
@@ -3695,7 +3695,7 @@
             <a:avLst/>
           </a:prstGeom>
           <a:solidFill>
-            <a:srgbClr val="13807C"/>
+            <a:srgbClr val="0C7A80"/>
           </a:solidFill>
           <a:ln>
             <a:noFill/>
@@ -3726,7 +3726,7 @@
       </p:sp>
       <p:pic>
         <p:nvPicPr>
-          <p:cNvPr id="18" name="Picture 17" descr="his_icon4.png"/>
+          <p:cNvPr id="18" name="Picture 17" descr="fp_icon4.png"/>
           <p:cNvPicPr>
             <a:picLocks noChangeAspect="1"/>
           </p:cNvPicPr>
@@ -3781,7 +3781,7 @@
             <a:r>
               <a:rPr sz="750" b="0" cap="all" spc="130">
                 <a:solidFill>
-                  <a:srgbClr val="D3E8E6"/>
+                  <a:srgbClr val="DCF2F3"/>
                 </a:solidFill>
                 <a:latin typeface="IBM Plex Mono"/>
               </a:rPr>
@@ -3791,7 +3791,7 @@
             <a:r>
               <a:rPr sz="750" b="0" cap="all" spc="130">
                 <a:solidFill>
-                  <a:srgbClr val="D3E8E6"/>
+                  <a:srgbClr val="DCF2F3"/>
                 </a:solidFill>
                 <a:latin typeface="IBM Plex Mono"/>
               </a:rPr>
@@ -3815,7 +3815,7 @@
             <a:avLst/>
           </a:prstGeom>
           <a:solidFill>
-            <a:srgbClr val="13807C"/>
+            <a:srgbClr val="0C7A80"/>
           </a:solidFill>
           <a:ln>
             <a:noFill/>
@@ -3846,7 +3846,7 @@
       </p:sp>
       <p:pic>
         <p:nvPicPr>
-          <p:cNvPr id="21" name="Picture 20" descr="his_icon5.png"/>
+          <p:cNvPr id="21" name="Picture 20" descr="fp_icon5.png"/>
           <p:cNvPicPr>
             <a:picLocks noChangeAspect="1"/>
           </p:cNvPicPr>
@@ -3901,7 +3901,7 @@
             <a:r>
               <a:rPr sz="750" b="0" cap="all" spc="130">
                 <a:solidFill>
-                  <a:srgbClr val="D3E8E6"/>
+                  <a:srgbClr val="DCF2F3"/>
                 </a:solidFill>
                 <a:latin typeface="IBM Plex Mono"/>
               </a:rPr>
@@ -3925,7 +3925,7 @@
             <a:avLst/>
           </a:prstGeom>
           <a:solidFill>
-            <a:srgbClr val="13807C"/>
+            <a:srgbClr val="0C7A80"/>
           </a:solidFill>
           <a:ln>
             <a:noFill/>
@@ -3956,7 +3956,7 @@
       </p:sp>
       <p:pic>
         <p:nvPicPr>
-          <p:cNvPr id="24" name="Picture 23" descr="his_icon6.png"/>
+          <p:cNvPr id="24" name="Picture 23" descr="fp_icon6.png"/>
           <p:cNvPicPr>
             <a:picLocks noChangeAspect="1"/>
           </p:cNvPicPr>
@@ -4011,7 +4011,7 @@
             <a:r>
               <a:rPr sz="750" b="0" cap="all" spc="130">
                 <a:solidFill>
-                  <a:srgbClr val="D3E8E6"/>
+                  <a:srgbClr val="DCF2F3"/>
                 </a:solidFill>
                 <a:latin typeface="IBM Plex Mono"/>
               </a:rPr>
@@ -4035,7 +4035,7 @@
             <a:avLst/>
           </a:prstGeom>
           <a:solidFill>
-            <a:srgbClr val="2E7E7A"/>
+            <a:srgbClr val="2E8A90"/>
           </a:solidFill>
           <a:ln>
             <a:noFill/>
@@ -4121,7 +4121,7 @@
             <a:r>
               <a:rPr sz="800" b="0" cap="all" spc="180">
                 <a:solidFill>
-                  <a:srgbClr val="9DC4C1"/>
+                  <a:srgbClr val="A9D6D9"/>
                 </a:solidFill>
                 <a:latin typeface="IBM Plex Mono"/>
               </a:rPr>
@@ -4211,7 +4211,7 @@
             <a:r>
               <a:rPr sz="750" b="0" cap="all" spc="160">
                 <a:solidFill>
-                  <a:srgbClr val="9DC4C1"/>
+                  <a:srgbClr val="A9D6D9"/>
                 </a:solidFill>
                 <a:latin typeface="IBM Plex Mono"/>
               </a:rPr>
@@ -4253,7 +4253,7 @@
             <a:r>
               <a:rPr sz="900" b="0">
                 <a:solidFill>
-                  <a:srgbClr val="8FA6A4"/>
+                  <a:srgbClr val="A9D6D9"/>
                 </a:solidFill>
                 <a:latin typeface="IBM Plex Mono"/>
               </a:rPr>
@@ -4295,7 +4295,7 @@
             <a:avLst/>
           </a:prstGeom>
           <a:solidFill>
-            <a:srgbClr val="FFFFFF"/>
+            <a:srgbClr val="FBFDFE"/>
           </a:solidFill>
           <a:ln>
             <a:noFill/>
@@ -4357,7 +4357,7 @@
             <a:r>
               <a:rPr sz="1000" b="0" cap="all" spc="240">
                 <a:solidFill>
-                  <a:srgbClr val="B55615"/>
+                  <a:srgbClr val="8A6608"/>
                 </a:solidFill>
                 <a:latin typeface="IBM Plex Mono"/>
               </a:rPr>
@@ -4399,7 +4399,7 @@
             <a:r>
               <a:rPr sz="2900" b="1">
                 <a:solidFill>
-                  <a:srgbClr val="17302E"/>
+                  <a:srgbClr val="0E2830"/>
                 </a:solidFill>
                 <a:latin typeface="Outfit"/>
               </a:rPr>
@@ -4425,11 +4425,11 @@
             </a:avLst>
           </a:prstGeom>
           <a:solidFill>
-            <a:srgbClr val="F2F8F7"/>
+            <a:srgbClr val="F0F7F8"/>
           </a:solidFill>
           <a:ln w="12700">
             <a:solidFill>
-              <a:srgbClr val="DCEAE8"/>
+              <a:srgbClr val="DCEAED"/>
             </a:solidFill>
           </a:ln>
           <a:effectLst/>
@@ -4489,7 +4489,7 @@
             <a:r>
               <a:rPr sz="800" b="0" cap="all" spc="180">
                 <a:solidFill>
-                  <a:srgbClr val="5D7573"/>
+                  <a:srgbClr val="52737D"/>
                 </a:solidFill>
                 <a:latin typeface="IBM Plex Mono"/>
               </a:rPr>
@@ -4531,7 +4531,7 @@
             <a:r>
               <a:rPr sz="1200" b="1">
                 <a:solidFill>
-                  <a:srgbClr val="17302E"/>
+                  <a:srgbClr val="0E2830"/>
                 </a:solidFill>
                 <a:latin typeface="Outfit"/>
               </a:rPr>
@@ -4555,7 +4555,7 @@
             <a:avLst/>
           </a:prstGeom>
           <a:solidFill>
-            <a:srgbClr val="0E6B68"/>
+            <a:srgbClr val="E9B949"/>
           </a:solidFill>
           <a:ln>
             <a:noFill/>
@@ -4617,7 +4617,7 @@
             <a:r>
               <a:rPr sz="919" b="0">
                 <a:solidFill>
-                  <a:srgbClr val="5A7674"/>
+                  <a:srgbClr val="33555F"/>
                 </a:solidFill>
                 <a:latin typeface="Plus Jakarta Sans"/>
               </a:rPr>
@@ -4641,7 +4641,7 @@
             <a:avLst/>
           </a:prstGeom>
           <a:solidFill>
-            <a:srgbClr val="0E6B68"/>
+            <a:srgbClr val="E9B949"/>
           </a:solidFill>
           <a:ln>
             <a:noFill/>
@@ -4703,7 +4703,7 @@
             <a:r>
               <a:rPr sz="919" b="0">
                 <a:solidFill>
-                  <a:srgbClr val="5A7674"/>
+                  <a:srgbClr val="33555F"/>
                 </a:solidFill>
                 <a:latin typeface="Plus Jakarta Sans"/>
               </a:rPr>
@@ -4727,7 +4727,7 @@
             <a:avLst/>
           </a:prstGeom>
           <a:solidFill>
-            <a:srgbClr val="0E6B68"/>
+            <a:srgbClr val="E9B949"/>
           </a:solidFill>
           <a:ln>
             <a:noFill/>
@@ -4789,7 +4789,7 @@
             <a:r>
               <a:rPr sz="919" b="0">
                 <a:solidFill>
-                  <a:srgbClr val="5A7674"/>
+                  <a:srgbClr val="33555F"/>
                 </a:solidFill>
                 <a:latin typeface="Plus Jakarta Sans"/>
               </a:rPr>
@@ -4813,7 +4813,7 @@
             <a:avLst/>
           </a:prstGeom>
           <a:solidFill>
-            <a:srgbClr val="0E6B68"/>
+            <a:srgbClr val="E9B949"/>
           </a:solidFill>
           <a:ln>
             <a:noFill/>
@@ -4875,7 +4875,7 @@
             <a:r>
               <a:rPr sz="919" b="0">
                 <a:solidFill>
-                  <a:srgbClr val="5A7674"/>
+                  <a:srgbClr val="33555F"/>
                 </a:solidFill>
                 <a:latin typeface="Plus Jakarta Sans"/>
               </a:rPr>
@@ -4899,7 +4899,7 @@
             <a:avLst/>
           </a:prstGeom>
           <a:solidFill>
-            <a:srgbClr val="0E6B68"/>
+            <a:srgbClr val="E9B949"/>
           </a:solidFill>
           <a:ln>
             <a:noFill/>
@@ -4961,7 +4961,7 @@
             <a:r>
               <a:rPr sz="919" b="0">
                 <a:solidFill>
-                  <a:srgbClr val="5A7674"/>
+                  <a:srgbClr val="33555F"/>
                 </a:solidFill>
                 <a:latin typeface="Plus Jakarta Sans"/>
               </a:rPr>
@@ -4987,11 +4987,11 @@
             </a:avLst>
           </a:prstGeom>
           <a:solidFill>
-            <a:srgbClr val="FBDCE6"/>
+            <a:srgbClr val="FCE2F0"/>
           </a:solidFill>
           <a:ln w="12700">
             <a:solidFill>
-              <a:srgbClr val="E85C82"/>
+              <a:srgbClr val="F49CCB"/>
             </a:solidFill>
           </a:ln>
           <a:effectLst/>
@@ -5051,7 +5051,7 @@
             <a:r>
               <a:rPr sz="800" b="0" cap="all" spc="180">
                 <a:solidFill>
-                  <a:srgbClr val="C11B48"/>
+                  <a:srgbClr val="C10073"/>
                 </a:solidFill>
                 <a:latin typeface="IBM Plex Mono"/>
               </a:rPr>
@@ -5093,7 +5093,7 @@
             <a:r>
               <a:rPr sz="1200" b="1">
                 <a:solidFill>
-                  <a:srgbClr val="17302E"/>
+                  <a:srgbClr val="0E2830"/>
                 </a:solidFill>
                 <a:latin typeface="Outfit"/>
               </a:rPr>
@@ -5117,7 +5117,7 @@
             <a:avLst/>
           </a:prstGeom>
           <a:solidFill>
-            <a:srgbClr val="E85C82"/>
+            <a:srgbClr val="EC008C"/>
           </a:solidFill>
           <a:ln>
             <a:noFill/>
@@ -5179,7 +5179,7 @@
             <a:r>
               <a:rPr sz="919" b="0">
                 <a:solidFill>
-                  <a:srgbClr val="17302E"/>
+                  <a:srgbClr val="33555F"/>
                 </a:solidFill>
                 <a:latin typeface="Plus Jakarta Sans"/>
               </a:rPr>
@@ -5203,7 +5203,7 @@
             <a:avLst/>
           </a:prstGeom>
           <a:solidFill>
-            <a:srgbClr val="E85C82"/>
+            <a:srgbClr val="EC008C"/>
           </a:solidFill>
           <a:ln>
             <a:noFill/>
@@ -5265,7 +5265,7 @@
             <a:r>
               <a:rPr sz="919" b="0">
                 <a:solidFill>
-                  <a:srgbClr val="17302E"/>
+                  <a:srgbClr val="33555F"/>
                 </a:solidFill>
                 <a:latin typeface="Plus Jakarta Sans"/>
               </a:rPr>
@@ -5289,7 +5289,7 @@
             <a:avLst/>
           </a:prstGeom>
           <a:solidFill>
-            <a:srgbClr val="E85C82"/>
+            <a:srgbClr val="EC008C"/>
           </a:solidFill>
           <a:ln>
             <a:noFill/>
@@ -5351,7 +5351,7 @@
             <a:r>
               <a:rPr sz="919" b="0">
                 <a:solidFill>
-                  <a:srgbClr val="17302E"/>
+                  <a:srgbClr val="33555F"/>
                 </a:solidFill>
                 <a:latin typeface="Plus Jakarta Sans"/>
               </a:rPr>
@@ -5375,7 +5375,7 @@
             <a:avLst/>
           </a:prstGeom>
           <a:solidFill>
-            <a:srgbClr val="E85C82"/>
+            <a:srgbClr val="EC008C"/>
           </a:solidFill>
           <a:ln>
             <a:noFill/>
@@ -5437,7 +5437,7 @@
             <a:r>
               <a:rPr sz="919" b="0">
                 <a:solidFill>
-                  <a:srgbClr val="17302E"/>
+                  <a:srgbClr val="33555F"/>
                 </a:solidFill>
                 <a:latin typeface="Plus Jakarta Sans"/>
               </a:rPr>
@@ -5461,7 +5461,7 @@
             <a:avLst/>
           </a:prstGeom>
           <a:solidFill>
-            <a:srgbClr val="E85C82"/>
+            <a:srgbClr val="EC008C"/>
           </a:solidFill>
           <a:ln>
             <a:noFill/>
@@ -5523,7 +5523,7 @@
             <a:r>
               <a:rPr sz="919" b="0">
                 <a:solidFill>
-                  <a:srgbClr val="17302E"/>
+                  <a:srgbClr val="33555F"/>
                 </a:solidFill>
                 <a:latin typeface="Plus Jakarta Sans"/>
               </a:rPr>
@@ -5565,7 +5565,7 @@
             <a:r>
               <a:rPr sz="700" b="0" cap="all" spc="140">
                 <a:solidFill>
-                  <a:srgbClr val="8FA6A4"/>
+                  <a:srgbClr val="52737D"/>
                 </a:solidFill>
                 <a:latin typeface="IBM Plex Mono"/>
               </a:rPr>
@@ -5607,7 +5607,7 @@
             <a:r>
               <a:rPr sz="900" b="0">
                 <a:solidFill>
-                  <a:srgbClr val="8FA6A4"/>
+                  <a:srgbClr val="52737D"/>
                 </a:solidFill>
                 <a:latin typeface="IBM Plex Mono"/>
               </a:rPr>
@@ -5649,7 +5649,7 @@
             <a:avLst/>
           </a:prstGeom>
           <a:solidFill>
-            <a:srgbClr val="FFFFFF"/>
+            <a:srgbClr val="FBFDFE"/>
           </a:solidFill>
           <a:ln>
             <a:noFill/>
@@ -5711,7 +5711,7 @@
             <a:r>
               <a:rPr sz="1000" b="0" cap="all" spc="240">
                 <a:solidFill>
-                  <a:srgbClr val="B55615"/>
+                  <a:srgbClr val="8A6608"/>
                 </a:solidFill>
                 <a:latin typeface="IBM Plex Mono"/>
               </a:rPr>
@@ -5753,7 +5753,7 @@
             <a:r>
               <a:rPr sz="3000" b="1">
                 <a:solidFill>
-                  <a:srgbClr val="17302E"/>
+                  <a:srgbClr val="0E2830"/>
                 </a:solidFill>
                 <a:latin typeface="Outfit"/>
               </a:rPr>
@@ -5795,7 +5795,7 @@
             <a:r>
               <a:rPr sz="1200" b="0">
                 <a:solidFill>
-                  <a:srgbClr val="5A7674"/>
+                  <a:srgbClr val="52737D"/>
                 </a:solidFill>
                 <a:latin typeface="Plus Jakarta Sans"/>
               </a:rPr>
@@ -5821,11 +5821,11 @@
             </a:avLst>
           </a:prstGeom>
           <a:solidFill>
-            <a:srgbClr val="F2F8F7"/>
+            <a:srgbClr val="F0F7F8"/>
           </a:solidFill>
           <a:ln w="12700">
             <a:solidFill>
-              <a:srgbClr val="DCEAE8"/>
+              <a:srgbClr val="DCEAED"/>
             </a:solidFill>
           </a:ln>
           <a:effectLst/>
@@ -5885,7 +5885,7 @@
             <a:r>
               <a:rPr sz="1500" b="1">
                 <a:solidFill>
-                  <a:srgbClr val="B55615"/>
+                  <a:srgbClr val="8A6608"/>
                 </a:solidFill>
                 <a:latin typeface="Outfit"/>
               </a:rPr>
@@ -5904,7 +5904,7 @@
             <a:r>
               <a:rPr sz="950" b="1">
                 <a:solidFill>
-                  <a:srgbClr val="17302E"/>
+                  <a:srgbClr val="0E2830"/>
                 </a:solidFill>
                 <a:latin typeface="Outfit"/>
               </a:rPr>
@@ -5923,7 +5923,7 @@
             <a:r>
               <a:rPr sz="819" b="0">
                 <a:solidFill>
-                  <a:srgbClr val="5A7674"/>
+                  <a:srgbClr val="33555F"/>
                 </a:solidFill>
                 <a:latin typeface="Plus Jakarta Sans"/>
               </a:rPr>
@@ -5949,11 +5949,11 @@
             </a:avLst>
           </a:prstGeom>
           <a:solidFill>
-            <a:srgbClr val="F2F8F7"/>
+            <a:srgbClr val="F0F7F8"/>
           </a:solidFill>
           <a:ln w="12700">
             <a:solidFill>
-              <a:srgbClr val="DCEAE8"/>
+              <a:srgbClr val="DCEAED"/>
             </a:solidFill>
           </a:ln>
           <a:effectLst/>
@@ -6013,7 +6013,7 @@
             <a:r>
               <a:rPr sz="1500" b="1">
                 <a:solidFill>
-                  <a:srgbClr val="B55615"/>
+                  <a:srgbClr val="8A6608"/>
                 </a:solidFill>
                 <a:latin typeface="Outfit"/>
               </a:rPr>
@@ -6032,7 +6032,7 @@
             <a:r>
               <a:rPr sz="950" b="1">
                 <a:solidFill>
-                  <a:srgbClr val="17302E"/>
+                  <a:srgbClr val="0E2830"/>
                 </a:solidFill>
                 <a:latin typeface="Outfit"/>
               </a:rPr>
@@ -6051,7 +6051,7 @@
             <a:r>
               <a:rPr sz="819" b="0">
                 <a:solidFill>
-                  <a:srgbClr val="5A7674"/>
+                  <a:srgbClr val="33555F"/>
                 </a:solidFill>
                 <a:latin typeface="Plus Jakarta Sans"/>
               </a:rPr>
@@ -6077,11 +6077,11 @@
             </a:avLst>
           </a:prstGeom>
           <a:solidFill>
-            <a:srgbClr val="F2F8F7"/>
+            <a:srgbClr val="F0F7F8"/>
           </a:solidFill>
           <a:ln w="12700">
             <a:solidFill>
-              <a:srgbClr val="DCEAE8"/>
+              <a:srgbClr val="DCEAED"/>
             </a:solidFill>
           </a:ln>
           <a:effectLst/>
@@ -6141,7 +6141,7 @@
             <a:r>
               <a:rPr sz="1500" b="1">
                 <a:solidFill>
-                  <a:srgbClr val="B55615"/>
+                  <a:srgbClr val="8A6608"/>
                 </a:solidFill>
                 <a:latin typeface="Outfit"/>
               </a:rPr>
@@ -6160,7 +6160,7 @@
             <a:r>
               <a:rPr sz="950" b="1">
                 <a:solidFill>
-                  <a:srgbClr val="17302E"/>
+                  <a:srgbClr val="0E2830"/>
                 </a:solidFill>
                 <a:latin typeface="Outfit"/>
               </a:rPr>
@@ -6179,7 +6179,7 @@
             <a:r>
               <a:rPr sz="819" b="0">
                 <a:solidFill>
-                  <a:srgbClr val="5A7674"/>
+                  <a:srgbClr val="33555F"/>
                 </a:solidFill>
                 <a:latin typeface="Plus Jakarta Sans"/>
               </a:rPr>
@@ -6205,11 +6205,11 @@
             </a:avLst>
           </a:prstGeom>
           <a:solidFill>
-            <a:srgbClr val="F2F8F7"/>
+            <a:srgbClr val="F0F7F8"/>
           </a:solidFill>
           <a:ln w="12700">
             <a:solidFill>
-              <a:srgbClr val="DCEAE8"/>
+              <a:srgbClr val="DCEAED"/>
             </a:solidFill>
           </a:ln>
           <a:effectLst/>
@@ -6269,7 +6269,7 @@
             <a:r>
               <a:rPr sz="1500" b="1">
                 <a:solidFill>
-                  <a:srgbClr val="B55615"/>
+                  <a:srgbClr val="8A6608"/>
                 </a:solidFill>
                 <a:latin typeface="Outfit"/>
               </a:rPr>
@@ -6288,7 +6288,7 @@
             <a:r>
               <a:rPr sz="950" b="1">
                 <a:solidFill>
-                  <a:srgbClr val="17302E"/>
+                  <a:srgbClr val="0E2830"/>
                 </a:solidFill>
                 <a:latin typeface="Outfit"/>
               </a:rPr>
@@ -6307,7 +6307,7 @@
             <a:r>
               <a:rPr sz="819" b="0">
                 <a:solidFill>
-                  <a:srgbClr val="5A7674"/>
+                  <a:srgbClr val="33555F"/>
                 </a:solidFill>
                 <a:latin typeface="Plus Jakarta Sans"/>
               </a:rPr>
@@ -6333,11 +6333,11 @@
             </a:avLst>
           </a:prstGeom>
           <a:solidFill>
-            <a:srgbClr val="F2F8F7"/>
+            <a:srgbClr val="F0F7F8"/>
           </a:solidFill>
           <a:ln w="12700">
             <a:solidFill>
-              <a:srgbClr val="DCEAE8"/>
+              <a:srgbClr val="DCEAED"/>
             </a:solidFill>
           </a:ln>
           <a:effectLst/>
@@ -6397,7 +6397,7 @@
             <a:r>
               <a:rPr sz="1500" b="1">
                 <a:solidFill>
-                  <a:srgbClr val="B55615"/>
+                  <a:srgbClr val="8A6608"/>
                 </a:solidFill>
                 <a:latin typeface="Outfit"/>
               </a:rPr>
@@ -6416,7 +6416,7 @@
             <a:r>
               <a:rPr sz="950" b="1">
                 <a:solidFill>
-                  <a:srgbClr val="17302E"/>
+                  <a:srgbClr val="0E2830"/>
                 </a:solidFill>
                 <a:latin typeface="Outfit"/>
               </a:rPr>
@@ -6435,7 +6435,7 @@
             <a:r>
               <a:rPr sz="819" b="0">
                 <a:solidFill>
-                  <a:srgbClr val="5A7674"/>
+                  <a:srgbClr val="33555F"/>
                 </a:solidFill>
                 <a:latin typeface="Plus Jakarta Sans"/>
               </a:rPr>
@@ -6461,11 +6461,11 @@
             </a:avLst>
           </a:prstGeom>
           <a:solidFill>
-            <a:srgbClr val="0A4B49"/>
+            <a:srgbClr val="0A5F65"/>
           </a:solidFill>
           <a:ln w="12700">
             <a:solidFill>
-              <a:srgbClr val="0A4B49"/>
+              <a:srgbClr val="0A5F65"/>
             </a:solidFill>
           </a:ln>
           <a:effectLst/>
@@ -6525,7 +6525,7 @@
             <a:r>
               <a:rPr sz="1500" b="1">
                 <a:solidFill>
-                  <a:srgbClr val="ED9D67"/>
+                  <a:srgbClr val="FFD264"/>
                 </a:solidFill>
                 <a:latin typeface="Outfit"/>
               </a:rPr>
@@ -6563,7 +6563,7 @@
             <a:r>
               <a:rPr sz="819" b="0">
                 <a:solidFill>
-                  <a:srgbClr val="D3E8E6"/>
+                  <a:srgbClr val="DCF2F3"/>
                 </a:solidFill>
                 <a:latin typeface="Plus Jakarta Sans"/>
               </a:rPr>
@@ -6589,11 +6589,11 @@
             </a:avLst>
           </a:prstGeom>
           <a:solidFill>
-            <a:srgbClr val="FBDCE6"/>
+            <a:srgbClr val="FCE2F0"/>
           </a:solidFill>
           <a:ln w="12700">
             <a:solidFill>
-              <a:srgbClr val="E85C82"/>
+              <a:srgbClr val="F49CCB"/>
             </a:solidFill>
           </a:ln>
           <a:effectLst/>
@@ -6653,7 +6653,7 @@
             <a:r>
               <a:rPr sz="800" b="0" cap="all" spc="180">
                 <a:solidFill>
-                  <a:srgbClr val="C11B48"/>
+                  <a:srgbClr val="C10073"/>
                 </a:solidFill>
                 <a:latin typeface="IBM Plex Mono"/>
               </a:rPr>
@@ -6672,7 +6672,7 @@
             <a:r>
               <a:rPr sz="1100" b="0">
                 <a:solidFill>
-                  <a:srgbClr val="17302E"/>
+                  <a:srgbClr val="33555F"/>
                 </a:solidFill>
                 <a:latin typeface="Plus Jakarta Sans"/>
               </a:rPr>
@@ -6714,7 +6714,7 @@
             <a:r>
               <a:rPr sz="700" b="0" cap="all" spc="140">
                 <a:solidFill>
-                  <a:srgbClr val="8FA6A4"/>
+                  <a:srgbClr val="52737D"/>
                 </a:solidFill>
                 <a:latin typeface="IBM Plex Mono"/>
               </a:rPr>
@@ -6756,7 +6756,7 @@
             <a:r>
               <a:rPr sz="900" b="0">
                 <a:solidFill>
-                  <a:srgbClr val="8FA6A4"/>
+                  <a:srgbClr val="52737D"/>
                 </a:solidFill>
                 <a:latin typeface="IBM Plex Mono"/>
               </a:rPr>
@@ -6798,7 +6798,7 @@
             <a:avLst/>
           </a:prstGeom>
           <a:solidFill>
-            <a:srgbClr val="FFFFFF"/>
+            <a:srgbClr val="FBFDFE"/>
           </a:solidFill>
           <a:ln>
             <a:noFill/>
@@ -6860,7 +6860,7 @@
             <a:r>
               <a:rPr sz="1000" b="0" cap="all" spc="240">
                 <a:solidFill>
-                  <a:srgbClr val="B55615"/>
+                  <a:srgbClr val="8A6608"/>
                 </a:solidFill>
                 <a:latin typeface="IBM Plex Mono"/>
               </a:rPr>
@@ -6902,7 +6902,7 @@
             <a:r>
               <a:rPr sz="3000" b="1">
                 <a:solidFill>
-                  <a:srgbClr val="17302E"/>
+                  <a:srgbClr val="0E2830"/>
                 </a:solidFill>
                 <a:latin typeface="Outfit"/>
               </a:rPr>
@@ -6950,7 +6950,7 @@
                       <a:r>
                         <a:rPr sz="750" b="0" cap="all" spc="140">
                           <a:solidFill>
-                            <a:srgbClr val="5D7573"/>
+                            <a:srgbClr val="52737D"/>
                           </a:solidFill>
                           <a:latin typeface="IBM Plex Mono"/>
                         </a:rPr>
@@ -6960,7 +6960,7 @@
                   </a:txBody>
                   <a:tcPr marL="54864" marR="54864" marT="36576" marB="36576" anchor="b">
                     <a:solidFill>
-                      <a:srgbClr val="FFFFFF"/>
+                      <a:srgbClr val="FBFDFE"/>
                     </a:solidFill>
                   </a:tcPr>
                 </a:tc>
@@ -6980,7 +6980,7 @@
                       <a:r>
                         <a:rPr sz="750" b="0" cap="all" spc="140">
                           <a:solidFill>
-                            <a:srgbClr val="5D7573"/>
+                            <a:srgbClr val="52737D"/>
                           </a:solidFill>
                           <a:latin typeface="IBM Plex Mono"/>
                         </a:rPr>
@@ -6990,7 +6990,7 @@
                   </a:txBody>
                   <a:tcPr marL="54864" marR="54864" marT="36576" marB="36576" anchor="b">
                     <a:solidFill>
-                      <a:srgbClr val="FFFFFF"/>
+                      <a:srgbClr val="FBFDFE"/>
                     </a:solidFill>
                   </a:tcPr>
                 </a:tc>
@@ -7012,7 +7012,7 @@
                       <a:r>
                         <a:rPr sz="1000" b="0">
                           <a:solidFill>
-                            <a:srgbClr val="17302E"/>
+                            <a:srgbClr val="33555F"/>
                           </a:solidFill>
                           <a:latin typeface="Plus Jakarta Sans"/>
                         </a:rPr>
@@ -7042,7 +7042,7 @@
                       <a:r>
                         <a:rPr sz="1000" b="0">
                           <a:solidFill>
-                            <a:srgbClr val="17302E"/>
+                            <a:srgbClr val="33555F"/>
                           </a:solidFill>
                           <a:latin typeface="Plus Jakarta Sans"/>
                         </a:rPr>
@@ -7074,11 +7074,73 @@
                       <a:r>
                         <a:rPr sz="1000" b="0">
                           <a:solidFill>
-                            <a:srgbClr val="17302E"/>
+                            <a:srgbClr val="33555F"/>
                           </a:solidFill>
                           <a:latin typeface="Plus Jakarta Sans"/>
                         </a:rPr>
                         <a:t>Add: Cargo Sales Collection</a:t>
+                      </a:r>
+                    </a:p>
+                  </a:txBody>
+                  <a:tcPr marL="54864" marR="54864" marT="45720" marB="45720" anchor="t">
+                    <a:solidFill>
+                      <a:srgbClr val="FBFDFE"/>
+                    </a:solidFill>
+                  </a:tcPr>
+                </a:tc>
+                <a:tc>
+                  <a:txBody>
+                    <a:bodyPr/>
+                    <a:lstStyle/>
+                    <a:p>
+                      <a:pPr>
+                        <a:lnSpc>
+                          <a:spcPct val="130000"/>
+                        </a:lnSpc>
+                        <a:spcAft>
+                          <a:spcPts val="0"/>
+                        </a:spcAft>
+                      </a:pPr>
+                      <a:r>
+                        <a:rPr sz="1000" b="0">
+                          <a:solidFill>
+                            <a:srgbClr val="33555F"/>
+                          </a:solidFill>
+                          <a:latin typeface="Plus Jakarta Sans"/>
+                        </a:rPr>
+                        <a:t>XXX</a:t>
+                      </a:r>
+                    </a:p>
+                  </a:txBody>
+                  <a:tcPr marL="54864" marR="54864" marT="45720" marB="45720" anchor="t">
+                    <a:solidFill>
+                      <a:srgbClr val="FBFDFE"/>
+                    </a:solidFill>
+                  </a:tcPr>
+                </a:tc>
+              </a:tr>
+              <a:tr h="324612">
+                <a:tc>
+                  <a:txBody>
+                    <a:bodyPr/>
+                    <a:lstStyle/>
+                    <a:p>
+                      <a:pPr>
+                        <a:lnSpc>
+                          <a:spcPct val="130000"/>
+                        </a:lnSpc>
+                        <a:spcAft>
+                          <a:spcPts val="0"/>
+                        </a:spcAft>
+                      </a:pPr>
+                      <a:r>
+                        <a:rPr sz="1000" b="0">
+                          <a:solidFill>
+                            <a:srgbClr val="33555F"/>
+                          </a:solidFill>
+                          <a:latin typeface="Plus Jakarta Sans"/>
+                        </a:rPr>
+                        <a:t>Add: Airline's Over-the-Counter Sale</a:t>
                       </a:r>
                     </a:p>
                   </a:txBody>
@@ -7104,7 +7166,7 @@
                       <a:r>
                         <a:rPr sz="1000" b="0">
                           <a:solidFill>
-                            <a:srgbClr val="17302E"/>
+                            <a:srgbClr val="33555F"/>
                           </a:solidFill>
                           <a:latin typeface="Plus Jakarta Sans"/>
                         </a:rPr>
@@ -7136,11 +7198,197 @@
                       <a:r>
                         <a:rPr sz="1000" b="0">
                           <a:solidFill>
-                            <a:srgbClr val="17302E"/>
+                            <a:srgbClr val="33555F"/>
                           </a:solidFill>
                           <a:latin typeface="Plus Jakarta Sans"/>
                         </a:rPr>
-                        <a:t>Add: Airline's Over-the-Counter Sale</a:t>
+                        <a:t>Add: Misc. Receipts (excess baggage, postal earnings, extra charges)</a:t>
+                      </a:r>
+                    </a:p>
+                  </a:txBody>
+                  <a:tcPr marL="54864" marR="54864" marT="45720" marB="45720" anchor="t">
+                    <a:solidFill>
+                      <a:srgbClr val="FBFDFE"/>
+                    </a:solidFill>
+                  </a:tcPr>
+                </a:tc>
+                <a:tc>
+                  <a:txBody>
+                    <a:bodyPr/>
+                    <a:lstStyle/>
+                    <a:p>
+                      <a:pPr>
+                        <a:lnSpc>
+                          <a:spcPct val="130000"/>
+                        </a:lnSpc>
+                        <a:spcAft>
+                          <a:spcPts val="0"/>
+                        </a:spcAft>
+                      </a:pPr>
+                      <a:r>
+                        <a:rPr sz="1000" b="0">
+                          <a:solidFill>
+                            <a:srgbClr val="33555F"/>
+                          </a:solidFill>
+                          <a:latin typeface="Plus Jakarta Sans"/>
+                        </a:rPr>
+                        <a:t>XXX</a:t>
+                      </a:r>
+                    </a:p>
+                  </a:txBody>
+                  <a:tcPr marL="54864" marR="54864" marT="45720" marB="45720" anchor="t">
+                    <a:solidFill>
+                      <a:srgbClr val="FBFDFE"/>
+                    </a:solidFill>
+                  </a:tcPr>
+                </a:tc>
+              </a:tr>
+              <a:tr h="324612">
+                <a:tc>
+                  <a:txBody>
+                    <a:bodyPr/>
+                    <a:lstStyle/>
+                    <a:p>
+                      <a:pPr>
+                        <a:lnSpc>
+                          <a:spcPct val="130000"/>
+                        </a:lnSpc>
+                        <a:spcAft>
+                          <a:spcPts val="0"/>
+                        </a:spcAft>
+                      </a:pPr>
+                      <a:r>
+                        <a:rPr sz="1000" b="1">
+                          <a:solidFill>
+                            <a:srgbClr val="0E2830"/>
+                          </a:solidFill>
+                          <a:latin typeface="Plus Jakarta Sans"/>
+                        </a:rPr>
+                        <a:t>A.  Total Collection for the Month</a:t>
+                      </a:r>
+                    </a:p>
+                  </a:txBody>
+                  <a:tcPr marL="54864" marR="54864" marT="45720" marB="45720" anchor="t">
+                    <a:solidFill>
+                      <a:srgbClr val="F0F7F8"/>
+                    </a:solidFill>
+                  </a:tcPr>
+                </a:tc>
+                <a:tc>
+                  <a:txBody>
+                    <a:bodyPr/>
+                    <a:lstStyle/>
+                    <a:p>
+                      <a:pPr>
+                        <a:lnSpc>
+                          <a:spcPct val="130000"/>
+                        </a:lnSpc>
+                        <a:spcAft>
+                          <a:spcPts val="0"/>
+                        </a:spcAft>
+                      </a:pPr>
+                      <a:r>
+                        <a:rPr sz="1000" b="1">
+                          <a:solidFill>
+                            <a:srgbClr val="0E2830"/>
+                          </a:solidFill>
+                          <a:latin typeface="Plus Jakarta Sans"/>
+                        </a:rPr>
+                        <a:t>XXXXXX</a:t>
+                      </a:r>
+                    </a:p>
+                  </a:txBody>
+                  <a:tcPr marL="54864" marR="54864" marT="45720" marB="45720" anchor="t">
+                    <a:solidFill>
+                      <a:srgbClr val="F0F7F8"/>
+                    </a:solidFill>
+                  </a:tcPr>
+                </a:tc>
+              </a:tr>
+              <a:tr h="324612">
+                <a:tc>
+                  <a:txBody>
+                    <a:bodyPr/>
+                    <a:lstStyle/>
+                    <a:p>
+                      <a:pPr>
+                        <a:lnSpc>
+                          <a:spcPct val="130000"/>
+                        </a:lnSpc>
+                        <a:spcAft>
+                          <a:spcPts val="0"/>
+                        </a:spcAft>
+                      </a:pPr>
+                      <a:r>
+                        <a:rPr sz="1000" b="0">
+                          <a:solidFill>
+                            <a:srgbClr val="33555F"/>
+                          </a:solidFill>
+                          <a:latin typeface="Plus Jakarta Sans"/>
+                        </a:rPr>
+                        <a:t>Less: Disbursement for the Month</a:t>
+                      </a:r>
+                    </a:p>
+                  </a:txBody>
+                  <a:tcPr marL="54864" marR="54864" marT="45720" marB="45720" anchor="t">
+                    <a:solidFill>
+                      <a:srgbClr val="FBFDFE"/>
+                    </a:solidFill>
+                  </a:tcPr>
+                </a:tc>
+                <a:tc>
+                  <a:txBody>
+                    <a:bodyPr/>
+                    <a:lstStyle/>
+                    <a:p>
+                      <a:pPr>
+                        <a:lnSpc>
+                          <a:spcPct val="130000"/>
+                        </a:lnSpc>
+                        <a:spcAft>
+                          <a:spcPts val="0"/>
+                        </a:spcAft>
+                      </a:pPr>
+                      <a:r>
+                        <a:rPr sz="1000" b="0">
+                          <a:solidFill>
+                            <a:srgbClr val="33555F"/>
+                          </a:solidFill>
+                          <a:latin typeface="Plus Jakarta Sans"/>
+                        </a:rPr>
+                        <a:t>XXX</a:t>
+                      </a:r>
+                    </a:p>
+                  </a:txBody>
+                  <a:tcPr marL="54864" marR="54864" marT="45720" marB="45720" anchor="t">
+                    <a:solidFill>
+                      <a:srgbClr val="FBFDFE"/>
+                    </a:solidFill>
+                  </a:tcPr>
+                </a:tc>
+              </a:tr>
+              <a:tr h="324612">
+                <a:tc>
+                  <a:txBody>
+                    <a:bodyPr/>
+                    <a:lstStyle/>
+                    <a:p>
+                      <a:pPr>
+                        <a:lnSpc>
+                          <a:spcPct val="130000"/>
+                        </a:lnSpc>
+                        <a:spcAft>
+                          <a:spcPts val="0"/>
+                        </a:spcAft>
+                      </a:pPr>
+                      <a:r>
+                        <a:rPr sz="1000" b="0">
+                          <a:solidFill>
+                            <a:srgbClr val="33555F"/>
+                          </a:solidFill>
+                          <a:latin typeface="Plus Jakarta Sans"/>
+                        </a:rPr>
+                        <a:t>Less: Other Adjustment</a:t>
                       </a:r>
                     </a:p>
                   </a:txBody>
@@ -7166,7 +7414,131 @@
                       <a:r>
                         <a:rPr sz="1000" b="0">
                           <a:solidFill>
-                            <a:srgbClr val="17302E"/>
+                            <a:srgbClr val="33555F"/>
+                          </a:solidFill>
+                          <a:latin typeface="Plus Jakarta Sans"/>
+                        </a:rPr>
+                        <a:t>XXX</a:t>
+                      </a:r>
+                    </a:p>
+                  </a:txBody>
+                  <a:tcPr marL="54864" marR="54864" marT="45720" marB="45720" anchor="t">
+                    <a:solidFill>
+                      <a:srgbClr val="FFFFFF"/>
+                    </a:solidFill>
+                  </a:tcPr>
+                </a:tc>
+              </a:tr>
+              <a:tr h="324612">
+                <a:tc>
+                  <a:txBody>
+                    <a:bodyPr/>
+                    <a:lstStyle/>
+                    <a:p>
+                      <a:pPr>
+                        <a:lnSpc>
+                          <a:spcPct val="130000"/>
+                        </a:lnSpc>
+                        <a:spcAft>
+                          <a:spcPts val="0"/>
+                        </a:spcAft>
+                      </a:pPr>
+                      <a:r>
+                        <a:rPr sz="1000" b="1">
+                          <a:solidFill>
+                            <a:srgbClr val="0E2830"/>
+                          </a:solidFill>
+                          <a:latin typeface="Plus Jakarta Sans"/>
+                        </a:rPr>
+                        <a:t>B.  Total Disbursement for the Month</a:t>
+                      </a:r>
+                    </a:p>
+                  </a:txBody>
+                  <a:tcPr marL="54864" marR="54864" marT="45720" marB="45720" anchor="t">
+                    <a:solidFill>
+                      <a:srgbClr val="F0F7F8"/>
+                    </a:solidFill>
+                  </a:tcPr>
+                </a:tc>
+                <a:tc>
+                  <a:txBody>
+                    <a:bodyPr/>
+                    <a:lstStyle/>
+                    <a:p>
+                      <a:pPr>
+                        <a:lnSpc>
+                          <a:spcPct val="130000"/>
+                        </a:lnSpc>
+                        <a:spcAft>
+                          <a:spcPts val="0"/>
+                        </a:spcAft>
+                      </a:pPr>
+                      <a:r>
+                        <a:rPr sz="1000" b="1">
+                          <a:solidFill>
+                            <a:srgbClr val="0E2830"/>
+                          </a:solidFill>
+                          <a:latin typeface="Plus Jakarta Sans"/>
+                        </a:rPr>
+                        <a:t>XXXXXX</a:t>
+                      </a:r>
+                    </a:p>
+                  </a:txBody>
+                  <a:tcPr marL="54864" marR="54864" marT="45720" marB="45720" anchor="t">
+                    <a:solidFill>
+                      <a:srgbClr val="F0F7F8"/>
+                    </a:solidFill>
+                  </a:tcPr>
+                </a:tc>
+              </a:tr>
+              <a:tr h="324612">
+                <a:tc>
+                  <a:txBody>
+                    <a:bodyPr/>
+                    <a:lstStyle/>
+                    <a:p>
+                      <a:pPr>
+                        <a:lnSpc>
+                          <a:spcPct val="130000"/>
+                        </a:lnSpc>
+                        <a:spcAft>
+                          <a:spcPts val="0"/>
+                        </a:spcAft>
+                      </a:pPr>
+                      <a:r>
+                        <a:rPr sz="1000" b="0">
+                          <a:solidFill>
+                            <a:srgbClr val="33555F"/>
+                          </a:solidFill>
+                          <a:latin typeface="Plus Jakarta Sans"/>
+                        </a:rPr>
+                        <a:t>i.  Provision for refund, 10% of passenger revenue (current month)</a:t>
+                      </a:r>
+                    </a:p>
+                  </a:txBody>
+                  <a:tcPr marL="54864" marR="54864" marT="45720" marB="45720" anchor="t">
+                    <a:solidFill>
+                      <a:srgbClr val="FFFFFF"/>
+                    </a:solidFill>
+                  </a:tcPr>
+                </a:tc>
+                <a:tc>
+                  <a:txBody>
+                    <a:bodyPr/>
+                    <a:lstStyle/>
+                    <a:p>
+                      <a:pPr>
+                        <a:lnSpc>
+                          <a:spcPct val="130000"/>
+                        </a:lnSpc>
+                        <a:spcAft>
+                          <a:spcPts val="0"/>
+                        </a:spcAft>
+                      </a:pPr>
+                      <a:r>
+                        <a:rPr sz="1000" b="0">
+                          <a:solidFill>
+                            <a:srgbClr val="33555F"/>
                           </a:solidFill>
                           <a:latin typeface="Plus Jakarta Sans"/>
                         </a:rPr>
@@ -7198,17 +7570,17 @@
                       <a:r>
                         <a:rPr sz="1000" b="0">
                           <a:solidFill>
-                            <a:srgbClr val="17302E"/>
+                            <a:srgbClr val="33555F"/>
                           </a:solidFill>
                           <a:latin typeface="Plus Jakarta Sans"/>
                         </a:rPr>
-                        <a:t>Add: Misc. Receipts (excess baggage, postal earnings, extra charges)</a:t>
+                        <a:t>ii.  Unused provision for refund, earlier period (previous month)</a:t>
                       </a:r>
                     </a:p>
                   </a:txBody>
                   <a:tcPr marL="54864" marR="54864" marT="45720" marB="45720" anchor="t">
                     <a:solidFill>
-                      <a:srgbClr val="FFFFFF"/>
+                      <a:srgbClr val="FBFDFE"/>
                     </a:solidFill>
                   </a:tcPr>
                 </a:tc>
@@ -7228,7 +7600,7 @@
                       <a:r>
                         <a:rPr sz="1000" b="0">
                           <a:solidFill>
-                            <a:srgbClr val="17302E"/>
+                            <a:srgbClr val="33555F"/>
                           </a:solidFill>
                           <a:latin typeface="Plus Jakarta Sans"/>
                         </a:rPr>
@@ -7238,7 +7610,7 @@
                   </a:txBody>
                   <a:tcPr marL="54864" marR="54864" marT="45720" marB="45720" anchor="t">
                     <a:solidFill>
-                      <a:srgbClr val="FFFFFF"/>
+                      <a:srgbClr val="FBFDFE"/>
                     </a:solidFill>
                   </a:tcPr>
                 </a:tc>
@@ -7260,17 +7632,17 @@
                       <a:r>
                         <a:rPr sz="1000" b="1">
                           <a:solidFill>
-                            <a:srgbClr val="17302E"/>
+                            <a:srgbClr val="0E2830"/>
                           </a:solidFill>
                           <a:latin typeface="Plus Jakarta Sans"/>
                         </a:rPr>
-                        <a:t>A.  Total Collection for the Month</a:t>
+                        <a:t>C.  Net Provision (i - ii)</a:t>
                       </a:r>
                     </a:p>
                   </a:txBody>
                   <a:tcPr marL="54864" marR="54864" marT="45720" marB="45720" anchor="t">
                     <a:solidFill>
-                      <a:srgbClr val="F2F8F7"/>
+                      <a:srgbClr val="F0F7F8"/>
                     </a:solidFill>
                   </a:tcPr>
                 </a:tc>
@@ -7290,7 +7662,7 @@
                       <a:r>
                         <a:rPr sz="1000" b="1">
                           <a:solidFill>
-                            <a:srgbClr val="17302E"/>
+                            <a:srgbClr val="0E2830"/>
                           </a:solidFill>
                           <a:latin typeface="Plus Jakarta Sans"/>
                         </a:rPr>
@@ -7300,379 +7672,7 @@
                   </a:txBody>
                   <a:tcPr marL="54864" marR="54864" marT="45720" marB="45720" anchor="t">
                     <a:solidFill>
-                      <a:srgbClr val="F2F8F7"/>
-                    </a:solidFill>
-                  </a:tcPr>
-                </a:tc>
-              </a:tr>
-              <a:tr h="324612">
-                <a:tc>
-                  <a:txBody>
-                    <a:bodyPr/>
-                    <a:lstStyle/>
-                    <a:p>
-                      <a:pPr>
-                        <a:lnSpc>
-                          <a:spcPct val="130000"/>
-                        </a:lnSpc>
-                        <a:spcAft>
-                          <a:spcPts val="0"/>
-                        </a:spcAft>
-                      </a:pPr>
-                      <a:r>
-                        <a:rPr sz="1000" b="0">
-                          <a:solidFill>
-                            <a:srgbClr val="17302E"/>
-                          </a:solidFill>
-                          <a:latin typeface="Plus Jakarta Sans"/>
-                        </a:rPr>
-                        <a:t>Less: Disbursement for the Month</a:t>
-                      </a:r>
-                    </a:p>
-                  </a:txBody>
-                  <a:tcPr marL="54864" marR="54864" marT="45720" marB="45720" anchor="t">
-                    <a:solidFill>
-                      <a:srgbClr val="FFFFFF"/>
-                    </a:solidFill>
-                  </a:tcPr>
-                </a:tc>
-                <a:tc>
-                  <a:txBody>
-                    <a:bodyPr/>
-                    <a:lstStyle/>
-                    <a:p>
-                      <a:pPr>
-                        <a:lnSpc>
-                          <a:spcPct val="130000"/>
-                        </a:lnSpc>
-                        <a:spcAft>
-                          <a:spcPts val="0"/>
-                        </a:spcAft>
-                      </a:pPr>
-                      <a:r>
-                        <a:rPr sz="1000" b="0">
-                          <a:solidFill>
-                            <a:srgbClr val="17302E"/>
-                          </a:solidFill>
-                          <a:latin typeface="Plus Jakarta Sans"/>
-                        </a:rPr>
-                        <a:t>XXX</a:t>
-                      </a:r>
-                    </a:p>
-                  </a:txBody>
-                  <a:tcPr marL="54864" marR="54864" marT="45720" marB="45720" anchor="t">
-                    <a:solidFill>
-                      <a:srgbClr val="FFFFFF"/>
-                    </a:solidFill>
-                  </a:tcPr>
-                </a:tc>
-              </a:tr>
-              <a:tr h="324612">
-                <a:tc>
-                  <a:txBody>
-                    <a:bodyPr/>
-                    <a:lstStyle/>
-                    <a:p>
-                      <a:pPr>
-                        <a:lnSpc>
-                          <a:spcPct val="130000"/>
-                        </a:lnSpc>
-                        <a:spcAft>
-                          <a:spcPts val="0"/>
-                        </a:spcAft>
-                      </a:pPr>
-                      <a:r>
-                        <a:rPr sz="1000" b="0">
-                          <a:solidFill>
-                            <a:srgbClr val="17302E"/>
-                          </a:solidFill>
-                          <a:latin typeface="Plus Jakarta Sans"/>
-                        </a:rPr>
-                        <a:t>Less: Other Adjustment</a:t>
-                      </a:r>
-                    </a:p>
-                  </a:txBody>
-                  <a:tcPr marL="54864" marR="54864" marT="45720" marB="45720" anchor="t">
-                    <a:solidFill>
-                      <a:srgbClr val="FFFFFF"/>
-                    </a:solidFill>
-                  </a:tcPr>
-                </a:tc>
-                <a:tc>
-                  <a:txBody>
-                    <a:bodyPr/>
-                    <a:lstStyle/>
-                    <a:p>
-                      <a:pPr>
-                        <a:lnSpc>
-                          <a:spcPct val="130000"/>
-                        </a:lnSpc>
-                        <a:spcAft>
-                          <a:spcPts val="0"/>
-                        </a:spcAft>
-                      </a:pPr>
-                      <a:r>
-                        <a:rPr sz="1000" b="0">
-                          <a:solidFill>
-                            <a:srgbClr val="17302E"/>
-                          </a:solidFill>
-                          <a:latin typeface="Plus Jakarta Sans"/>
-                        </a:rPr>
-                        <a:t>XXX</a:t>
-                      </a:r>
-                    </a:p>
-                  </a:txBody>
-                  <a:tcPr marL="54864" marR="54864" marT="45720" marB="45720" anchor="t">
-                    <a:solidFill>
-                      <a:srgbClr val="FFFFFF"/>
-                    </a:solidFill>
-                  </a:tcPr>
-                </a:tc>
-              </a:tr>
-              <a:tr h="324612">
-                <a:tc>
-                  <a:txBody>
-                    <a:bodyPr/>
-                    <a:lstStyle/>
-                    <a:p>
-                      <a:pPr>
-                        <a:lnSpc>
-                          <a:spcPct val="130000"/>
-                        </a:lnSpc>
-                        <a:spcAft>
-                          <a:spcPts val="0"/>
-                        </a:spcAft>
-                      </a:pPr>
-                      <a:r>
-                        <a:rPr sz="1000" b="1">
-                          <a:solidFill>
-                            <a:srgbClr val="17302E"/>
-                          </a:solidFill>
-                          <a:latin typeface="Plus Jakarta Sans"/>
-                        </a:rPr>
-                        <a:t>B.  Total Disbursement for the Month</a:t>
-                      </a:r>
-                    </a:p>
-                  </a:txBody>
-                  <a:tcPr marL="54864" marR="54864" marT="45720" marB="45720" anchor="t">
-                    <a:solidFill>
-                      <a:srgbClr val="F2F8F7"/>
-                    </a:solidFill>
-                  </a:tcPr>
-                </a:tc>
-                <a:tc>
-                  <a:txBody>
-                    <a:bodyPr/>
-                    <a:lstStyle/>
-                    <a:p>
-                      <a:pPr>
-                        <a:lnSpc>
-                          <a:spcPct val="130000"/>
-                        </a:lnSpc>
-                        <a:spcAft>
-                          <a:spcPts val="0"/>
-                        </a:spcAft>
-                      </a:pPr>
-                      <a:r>
-                        <a:rPr sz="1000" b="1">
-                          <a:solidFill>
-                            <a:srgbClr val="17302E"/>
-                          </a:solidFill>
-                          <a:latin typeface="Plus Jakarta Sans"/>
-                        </a:rPr>
-                        <a:t>XXXXXX</a:t>
-                      </a:r>
-                    </a:p>
-                  </a:txBody>
-                  <a:tcPr marL="54864" marR="54864" marT="45720" marB="45720" anchor="t">
-                    <a:solidFill>
-                      <a:srgbClr val="F2F8F7"/>
-                    </a:solidFill>
-                  </a:tcPr>
-                </a:tc>
-              </a:tr>
-              <a:tr h="324612">
-                <a:tc>
-                  <a:txBody>
-                    <a:bodyPr/>
-                    <a:lstStyle/>
-                    <a:p>
-                      <a:pPr>
-                        <a:lnSpc>
-                          <a:spcPct val="130000"/>
-                        </a:lnSpc>
-                        <a:spcAft>
-                          <a:spcPts val="0"/>
-                        </a:spcAft>
-                      </a:pPr>
-                      <a:r>
-                        <a:rPr sz="1000" b="0">
-                          <a:solidFill>
-                            <a:srgbClr val="17302E"/>
-                          </a:solidFill>
-                          <a:latin typeface="Plus Jakarta Sans"/>
-                        </a:rPr>
-                        <a:t>i.  Provision for refund, 10% of passenger revenue (current month)</a:t>
-                      </a:r>
-                    </a:p>
-                  </a:txBody>
-                  <a:tcPr marL="54864" marR="54864" marT="45720" marB="45720" anchor="t">
-                    <a:solidFill>
-                      <a:srgbClr val="FFFFFF"/>
-                    </a:solidFill>
-                  </a:tcPr>
-                </a:tc>
-                <a:tc>
-                  <a:txBody>
-                    <a:bodyPr/>
-                    <a:lstStyle/>
-                    <a:p>
-                      <a:pPr>
-                        <a:lnSpc>
-                          <a:spcPct val="130000"/>
-                        </a:lnSpc>
-                        <a:spcAft>
-                          <a:spcPts val="0"/>
-                        </a:spcAft>
-                      </a:pPr>
-                      <a:r>
-                        <a:rPr sz="1000" b="0">
-                          <a:solidFill>
-                            <a:srgbClr val="17302E"/>
-                          </a:solidFill>
-                          <a:latin typeface="Plus Jakarta Sans"/>
-                        </a:rPr>
-                        <a:t>XXX</a:t>
-                      </a:r>
-                    </a:p>
-                  </a:txBody>
-                  <a:tcPr marL="54864" marR="54864" marT="45720" marB="45720" anchor="t">
-                    <a:solidFill>
-                      <a:srgbClr val="FFFFFF"/>
-                    </a:solidFill>
-                  </a:tcPr>
-                </a:tc>
-              </a:tr>
-              <a:tr h="324612">
-                <a:tc>
-                  <a:txBody>
-                    <a:bodyPr/>
-                    <a:lstStyle/>
-                    <a:p>
-                      <a:pPr>
-                        <a:lnSpc>
-                          <a:spcPct val="130000"/>
-                        </a:lnSpc>
-                        <a:spcAft>
-                          <a:spcPts val="0"/>
-                        </a:spcAft>
-                      </a:pPr>
-                      <a:r>
-                        <a:rPr sz="1000" b="0">
-                          <a:solidFill>
-                            <a:srgbClr val="17302E"/>
-                          </a:solidFill>
-                          <a:latin typeface="Plus Jakarta Sans"/>
-                        </a:rPr>
-                        <a:t>ii.  Unused provision for refund, earlier period (previous month)</a:t>
-                      </a:r>
-                    </a:p>
-                  </a:txBody>
-                  <a:tcPr marL="54864" marR="54864" marT="45720" marB="45720" anchor="t">
-                    <a:solidFill>
-                      <a:srgbClr val="FFFFFF"/>
-                    </a:solidFill>
-                  </a:tcPr>
-                </a:tc>
-                <a:tc>
-                  <a:txBody>
-                    <a:bodyPr/>
-                    <a:lstStyle/>
-                    <a:p>
-                      <a:pPr>
-                        <a:lnSpc>
-                          <a:spcPct val="130000"/>
-                        </a:lnSpc>
-                        <a:spcAft>
-                          <a:spcPts val="0"/>
-                        </a:spcAft>
-                      </a:pPr>
-                      <a:r>
-                        <a:rPr sz="1000" b="0">
-                          <a:solidFill>
-                            <a:srgbClr val="17302E"/>
-                          </a:solidFill>
-                          <a:latin typeface="Plus Jakarta Sans"/>
-                        </a:rPr>
-                        <a:t>XXX</a:t>
-                      </a:r>
-                    </a:p>
-                  </a:txBody>
-                  <a:tcPr marL="54864" marR="54864" marT="45720" marB="45720" anchor="t">
-                    <a:solidFill>
-                      <a:srgbClr val="FFFFFF"/>
-                    </a:solidFill>
-                  </a:tcPr>
-                </a:tc>
-              </a:tr>
-              <a:tr h="324612">
-                <a:tc>
-                  <a:txBody>
-                    <a:bodyPr/>
-                    <a:lstStyle/>
-                    <a:p>
-                      <a:pPr>
-                        <a:lnSpc>
-                          <a:spcPct val="130000"/>
-                        </a:lnSpc>
-                        <a:spcAft>
-                          <a:spcPts val="0"/>
-                        </a:spcAft>
-                      </a:pPr>
-                      <a:r>
-                        <a:rPr sz="1000" b="1">
-                          <a:solidFill>
-                            <a:srgbClr val="17302E"/>
-                          </a:solidFill>
-                          <a:latin typeface="Plus Jakarta Sans"/>
-                        </a:rPr>
-                        <a:t>C.  Net Provision (i - ii)</a:t>
-                      </a:r>
-                    </a:p>
-                  </a:txBody>
-                  <a:tcPr marL="54864" marR="54864" marT="45720" marB="45720" anchor="t">
-                    <a:solidFill>
-                      <a:srgbClr val="F2F8F7"/>
-                    </a:solidFill>
-                  </a:tcPr>
-                </a:tc>
-                <a:tc>
-                  <a:txBody>
-                    <a:bodyPr/>
-                    <a:lstStyle/>
-                    <a:p>
-                      <a:pPr>
-                        <a:lnSpc>
-                          <a:spcPct val="130000"/>
-                        </a:lnSpc>
-                        <a:spcAft>
-                          <a:spcPts val="0"/>
-                        </a:spcAft>
-                      </a:pPr>
-                      <a:r>
-                        <a:rPr sz="1000" b="1">
-                          <a:solidFill>
-                            <a:srgbClr val="17302E"/>
-                          </a:solidFill>
-                          <a:latin typeface="Plus Jakarta Sans"/>
-                        </a:rPr>
-                        <a:t>XXXXXX</a:t>
-                      </a:r>
-                    </a:p>
-                  </a:txBody>
-                  <a:tcPr marL="54864" marR="54864" marT="45720" marB="45720" anchor="t">
-                    <a:solidFill>
-                      <a:srgbClr val="F2F8F7"/>
+                      <a:srgbClr val="F0F7F8"/>
                     </a:solidFill>
                   </a:tcPr>
                 </a:tc>
@@ -7704,7 +7704,7 @@
                   </a:txBody>
                   <a:tcPr marL="54864" marR="54864" marT="45720" marB="45720" anchor="t">
                     <a:solidFill>
-                      <a:srgbClr val="0A4B49"/>
+                      <a:srgbClr val="0A5F65"/>
                     </a:solidFill>
                   </a:tcPr>
                 </a:tc>
@@ -7734,7 +7734,7 @@
                   </a:txBody>
                   <a:tcPr marL="54864" marR="54864" marT="45720" marB="45720" anchor="t">
                     <a:solidFill>
-                      <a:srgbClr val="0A4B49"/>
+                      <a:srgbClr val="0A5F65"/>
                     </a:solidFill>
                   </a:tcPr>
                 </a:tc>
@@ -7776,7 +7776,7 @@
             <a:r>
               <a:rPr sz="700" b="0" cap="all" spc="140">
                 <a:solidFill>
-                  <a:srgbClr val="8FA6A4"/>
+                  <a:srgbClr val="52737D"/>
                 </a:solidFill>
                 <a:latin typeface="IBM Plex Mono"/>
               </a:rPr>
@@ -7818,7 +7818,7 @@
             <a:r>
               <a:rPr sz="900" b="0">
                 <a:solidFill>
-                  <a:srgbClr val="8FA6A4"/>
+                  <a:srgbClr val="52737D"/>
                 </a:solidFill>
                 <a:latin typeface="IBM Plex Mono"/>
               </a:rPr>
@@ -7860,7 +7860,7 @@
             <a:avLst/>
           </a:prstGeom>
           <a:solidFill>
-            <a:srgbClr val="FFFFFF"/>
+            <a:srgbClr val="FBFDFE"/>
           </a:solidFill>
           <a:ln>
             <a:noFill/>
@@ -7922,7 +7922,7 @@
             <a:r>
               <a:rPr sz="1000" b="0" cap="all" spc="240">
                 <a:solidFill>
-                  <a:srgbClr val="B55615"/>
+                  <a:srgbClr val="8A6608"/>
                 </a:solidFill>
                 <a:latin typeface="IBM Plex Mono"/>
               </a:rPr>
@@ -7964,7 +7964,7 @@
             <a:r>
               <a:rPr sz="2900" b="1">
                 <a:solidFill>
-                  <a:srgbClr val="17302E"/>
+                  <a:srgbClr val="0E2830"/>
                 </a:solidFill>
                 <a:latin typeface="Outfit"/>
               </a:rPr>
@@ -8006,7 +8006,7 @@
             <a:r>
               <a:rPr sz="800" b="0" cap="all" spc="180">
                 <a:solidFill>
-                  <a:srgbClr val="5D7573"/>
+                  <a:srgbClr val="52737D"/>
                 </a:solidFill>
                 <a:latin typeface="IBM Plex Mono"/>
               </a:rPr>
@@ -8032,11 +8032,11 @@
             </a:avLst>
           </a:prstGeom>
           <a:solidFill>
-            <a:srgbClr val="F2F8F7"/>
+            <a:srgbClr val="F0F7F8"/>
           </a:solidFill>
           <a:ln w="12700">
             <a:solidFill>
-              <a:srgbClr val="DCEAE8"/>
+              <a:srgbClr val="DCEAED"/>
             </a:solidFill>
           </a:ln>
           <a:effectLst/>
@@ -8096,7 +8096,7 @@
             <a:r>
               <a:rPr sz="1150" b="1">
                 <a:solidFill>
-                  <a:srgbClr val="17302E"/>
+                  <a:srgbClr val="0E2830"/>
                 </a:solidFill>
                 <a:latin typeface="Outfit"/>
               </a:rPr>
@@ -8115,7 +8115,7 @@
             <a:r>
               <a:rPr sz="950" b="0">
                 <a:solidFill>
-                  <a:srgbClr val="5A7674"/>
+                  <a:srgbClr val="33555F"/>
                 </a:solidFill>
                 <a:latin typeface="Plus Jakarta Sans"/>
               </a:rPr>
@@ -8141,11 +8141,11 @@
             </a:avLst>
           </a:prstGeom>
           <a:solidFill>
-            <a:srgbClr val="F2F8F7"/>
+            <a:srgbClr val="F0F7F8"/>
           </a:solidFill>
           <a:ln w="12700">
             <a:solidFill>
-              <a:srgbClr val="DCEAE8"/>
+              <a:srgbClr val="DCEAED"/>
             </a:solidFill>
           </a:ln>
           <a:effectLst/>
@@ -8205,7 +8205,7 @@
             <a:r>
               <a:rPr sz="1150" b="1">
                 <a:solidFill>
-                  <a:srgbClr val="17302E"/>
+                  <a:srgbClr val="0E2830"/>
                 </a:solidFill>
                 <a:latin typeface="Outfit"/>
               </a:rPr>
@@ -8224,7 +8224,7 @@
             <a:r>
               <a:rPr sz="950" b="0">
                 <a:solidFill>
-                  <a:srgbClr val="5A7674"/>
+                  <a:srgbClr val="33555F"/>
                 </a:solidFill>
                 <a:latin typeface="Plus Jakarta Sans"/>
               </a:rPr>
@@ -8250,11 +8250,11 @@
             </a:avLst>
           </a:prstGeom>
           <a:solidFill>
-            <a:srgbClr val="F2F8F7"/>
+            <a:srgbClr val="F0F7F8"/>
           </a:solidFill>
           <a:ln w="12700">
             <a:solidFill>
-              <a:srgbClr val="DCEAE8"/>
+              <a:srgbClr val="DCEAED"/>
             </a:solidFill>
           </a:ln>
           <a:effectLst/>
@@ -8314,7 +8314,7 @@
             <a:r>
               <a:rPr sz="1150" b="1">
                 <a:solidFill>
-                  <a:srgbClr val="17302E"/>
+                  <a:srgbClr val="0E2830"/>
                 </a:solidFill>
                 <a:latin typeface="Outfit"/>
               </a:rPr>
@@ -8333,7 +8333,7 @@
             <a:r>
               <a:rPr sz="950" b="0">
                 <a:solidFill>
-                  <a:srgbClr val="5A7674"/>
+                  <a:srgbClr val="33555F"/>
                 </a:solidFill>
                 <a:latin typeface="Plus Jakarta Sans"/>
               </a:rPr>
@@ -8375,7 +8375,7 @@
             <a:r>
               <a:rPr sz="800" b="0" cap="all" spc="180">
                 <a:solidFill>
-                  <a:srgbClr val="5D7573"/>
+                  <a:srgbClr val="52737D"/>
                 </a:solidFill>
                 <a:latin typeface="IBM Plex Mono"/>
               </a:rPr>
@@ -8401,11 +8401,11 @@
             </a:avLst>
           </a:prstGeom>
           <a:solidFill>
-            <a:srgbClr val="0A4B49"/>
+            <a:srgbClr val="0A5F65"/>
           </a:solidFill>
           <a:ln w="12700">
             <a:solidFill>
-              <a:srgbClr val="0A4B49"/>
+              <a:srgbClr val="0A5F65"/>
             </a:solidFill>
           </a:ln>
           <a:effectLst/>
@@ -8465,7 +8465,7 @@
             <a:r>
               <a:rPr sz="800" b="0" cap="all" spc="180">
                 <a:solidFill>
-                  <a:srgbClr val="9DC4C1"/>
+                  <a:srgbClr val="A9D6D9"/>
                 </a:solidFill>
                 <a:latin typeface="IBM Plex Mono"/>
               </a:rPr>
@@ -8489,7 +8489,7 @@
             <a:avLst/>
           </a:prstGeom>
           <a:solidFill>
-            <a:srgbClr val="E8823D"/>
+            <a:srgbClr val="E9B949"/>
           </a:solidFill>
           <a:ln>
             <a:noFill/>
@@ -8551,7 +8551,7 @@
             <a:r>
               <a:rPr sz="1000" b="0">
                 <a:solidFill>
-                  <a:srgbClr val="D3E8E6"/>
+                  <a:srgbClr val="DCF2F3"/>
                 </a:solidFill>
                 <a:latin typeface="Plus Jakarta Sans"/>
               </a:rPr>
@@ -8575,7 +8575,7 @@
             <a:avLst/>
           </a:prstGeom>
           <a:solidFill>
-            <a:srgbClr val="E8823D"/>
+            <a:srgbClr val="E9B949"/>
           </a:solidFill>
           <a:ln>
             <a:noFill/>
@@ -8637,7 +8637,7 @@
             <a:r>
               <a:rPr sz="1000" b="0">
                 <a:solidFill>
-                  <a:srgbClr val="D3E8E6"/>
+                  <a:srgbClr val="DCF2F3"/>
                 </a:solidFill>
                 <a:latin typeface="Plus Jakarta Sans"/>
               </a:rPr>
@@ -8661,7 +8661,7 @@
             <a:avLst/>
           </a:prstGeom>
           <a:solidFill>
-            <a:srgbClr val="E8823D"/>
+            <a:srgbClr val="E9B949"/>
           </a:solidFill>
           <a:ln>
             <a:noFill/>
@@ -8723,7 +8723,7 @@
             <a:r>
               <a:rPr sz="1000" b="0">
                 <a:solidFill>
-                  <a:srgbClr val="D3E8E6"/>
+                  <a:srgbClr val="DCF2F3"/>
                 </a:solidFill>
                 <a:latin typeface="Plus Jakarta Sans"/>
               </a:rPr>
@@ -8749,11 +8749,11 @@
             </a:avLst>
           </a:prstGeom>
           <a:solidFill>
-            <a:srgbClr val="F2F8F7"/>
+            <a:srgbClr val="F0F7F8"/>
           </a:solidFill>
           <a:ln w="12700">
             <a:solidFill>
-              <a:srgbClr val="DCEAE8"/>
+              <a:srgbClr val="DCEAED"/>
             </a:solidFill>
           </a:ln>
           <a:effectLst/>
@@ -8813,7 +8813,7 @@
             <a:r>
               <a:rPr sz="800" b="0" cap="all" spc="180">
                 <a:solidFill>
-                  <a:srgbClr val="5D7573"/>
+                  <a:srgbClr val="52737D"/>
                 </a:solidFill>
                 <a:latin typeface="IBM Plex Mono"/>
               </a:rPr>
@@ -8837,7 +8837,7 @@
             <a:avLst/>
           </a:prstGeom>
           <a:solidFill>
-            <a:srgbClr val="0E6B68"/>
+            <a:srgbClr val="E9B949"/>
           </a:solidFill>
           <a:ln>
             <a:noFill/>
@@ -8899,7 +8899,7 @@
             <a:r>
               <a:rPr sz="1000" b="0">
                 <a:solidFill>
-                  <a:srgbClr val="5A7674"/>
+                  <a:srgbClr val="33555F"/>
                 </a:solidFill>
                 <a:latin typeface="Plus Jakarta Sans"/>
               </a:rPr>
@@ -8923,7 +8923,7 @@
             <a:avLst/>
           </a:prstGeom>
           <a:solidFill>
-            <a:srgbClr val="0E6B68"/>
+            <a:srgbClr val="E9B949"/>
           </a:solidFill>
           <a:ln>
             <a:noFill/>
@@ -8985,7 +8985,7 @@
             <a:r>
               <a:rPr sz="1000" b="0">
                 <a:solidFill>
-                  <a:srgbClr val="5A7674"/>
+                  <a:srgbClr val="33555F"/>
                 </a:solidFill>
                 <a:latin typeface="Plus Jakarta Sans"/>
               </a:rPr>
@@ -9027,7 +9027,7 @@
             <a:r>
               <a:rPr sz="700" b="0" cap="all" spc="140">
                 <a:solidFill>
-                  <a:srgbClr val="8FA6A4"/>
+                  <a:srgbClr val="52737D"/>
                 </a:solidFill>
                 <a:latin typeface="IBM Plex Mono"/>
               </a:rPr>
@@ -9069,7 +9069,7 @@
             <a:r>
               <a:rPr sz="900" b="0">
                 <a:solidFill>
-                  <a:srgbClr val="8FA6A4"/>
+                  <a:srgbClr val="52737D"/>
                 </a:solidFill>
                 <a:latin typeface="IBM Plex Mono"/>
               </a:rPr>
@@ -9111,7 +9111,7 @@
             <a:avLst/>
           </a:prstGeom>
           <a:solidFill>
-            <a:srgbClr val="FFFFFF"/>
+            <a:srgbClr val="FBFDFE"/>
           </a:solidFill>
           <a:ln>
             <a:noFill/>
@@ -9173,7 +9173,7 @@
             <a:r>
               <a:rPr sz="1000" b="0" cap="all" spc="240">
                 <a:solidFill>
-                  <a:srgbClr val="B55615"/>
+                  <a:srgbClr val="8A6608"/>
                 </a:solidFill>
                 <a:latin typeface="IBM Plex Mono"/>
               </a:rPr>
@@ -9215,7 +9215,7 @@
             <a:r>
               <a:rPr sz="3000" b="1">
                 <a:solidFill>
-                  <a:srgbClr val="17302E"/>
+                  <a:srgbClr val="0E2830"/>
                 </a:solidFill>
                 <a:latin typeface="Outfit"/>
               </a:rPr>
@@ -9241,11 +9241,11 @@
             </a:avLst>
           </a:prstGeom>
           <a:solidFill>
-            <a:srgbClr val="F2F8F7"/>
+            <a:srgbClr val="F0F7F8"/>
           </a:solidFill>
           <a:ln w="12700">
             <a:solidFill>
-              <a:srgbClr val="DCEAE8"/>
+              <a:srgbClr val="DCEAED"/>
             </a:solidFill>
           </a:ln>
           <a:effectLst/>
@@ -9305,7 +9305,7 @@
             <a:r>
               <a:rPr sz="1000" b="0">
                 <a:solidFill>
-                  <a:srgbClr val="5A7674"/>
+                  <a:srgbClr val="33555F"/>
                 </a:solidFill>
                 <a:latin typeface="Plus Jakarta Sans"/>
               </a:rPr>
@@ -9331,11 +9331,11 @@
             </a:avLst>
           </a:prstGeom>
           <a:solidFill>
-            <a:srgbClr val="F2F8F7"/>
+            <a:srgbClr val="F0F7F8"/>
           </a:solidFill>
           <a:ln w="12700">
             <a:solidFill>
-              <a:srgbClr val="DCEAE8"/>
+              <a:srgbClr val="DCEAED"/>
             </a:solidFill>
           </a:ln>
           <a:effectLst/>
@@ -9395,7 +9395,7 @@
             <a:r>
               <a:rPr sz="1000" b="0">
                 <a:solidFill>
-                  <a:srgbClr val="5A7674"/>
+                  <a:srgbClr val="33555F"/>
                 </a:solidFill>
                 <a:latin typeface="Plus Jakarta Sans"/>
               </a:rPr>
@@ -9421,11 +9421,11 @@
             </a:avLst>
           </a:prstGeom>
           <a:solidFill>
-            <a:srgbClr val="F2F8F7"/>
+            <a:srgbClr val="F0F7F8"/>
           </a:solidFill>
           <a:ln w="12700">
             <a:solidFill>
-              <a:srgbClr val="DCEAE8"/>
+              <a:srgbClr val="DCEAED"/>
             </a:solidFill>
           </a:ln>
           <a:effectLst/>
@@ -9485,7 +9485,7 @@
             <a:r>
               <a:rPr sz="1000" b="0">
                 <a:solidFill>
-                  <a:srgbClr val="5A7674"/>
+                  <a:srgbClr val="33555F"/>
                 </a:solidFill>
                 <a:latin typeface="Plus Jakarta Sans"/>
               </a:rPr>
@@ -9511,11 +9511,11 @@
             </a:avLst>
           </a:prstGeom>
           <a:solidFill>
-            <a:srgbClr val="F2F8F7"/>
+            <a:srgbClr val="F0F7F8"/>
           </a:solidFill>
           <a:ln w="12700">
             <a:solidFill>
-              <a:srgbClr val="DCEAE8"/>
+              <a:srgbClr val="DCEAED"/>
             </a:solidFill>
           </a:ln>
           <a:effectLst/>
@@ -9575,7 +9575,7 @@
             <a:r>
               <a:rPr sz="1000" b="0">
                 <a:solidFill>
-                  <a:srgbClr val="5A7674"/>
+                  <a:srgbClr val="33555F"/>
                 </a:solidFill>
                 <a:latin typeface="Plus Jakarta Sans"/>
               </a:rPr>
@@ -9601,11 +9601,11 @@
             </a:avLst>
           </a:prstGeom>
           <a:solidFill>
-            <a:srgbClr val="F2F8F7"/>
+            <a:srgbClr val="F0F7F8"/>
           </a:solidFill>
           <a:ln w="12700">
             <a:solidFill>
-              <a:srgbClr val="DCEAE8"/>
+              <a:srgbClr val="DCEAED"/>
             </a:solidFill>
           </a:ln>
           <a:effectLst/>
@@ -9665,7 +9665,7 @@
             <a:r>
               <a:rPr sz="1000" b="0">
                 <a:solidFill>
-                  <a:srgbClr val="5A7674"/>
+                  <a:srgbClr val="33555F"/>
                 </a:solidFill>
                 <a:latin typeface="Plus Jakarta Sans"/>
               </a:rPr>
@@ -9691,11 +9691,11 @@
             </a:avLst>
           </a:prstGeom>
           <a:solidFill>
-            <a:srgbClr val="F2F8F7"/>
+            <a:srgbClr val="F0F7F8"/>
           </a:solidFill>
           <a:ln w="12700">
             <a:solidFill>
-              <a:srgbClr val="DCEAE8"/>
+              <a:srgbClr val="DCEAED"/>
             </a:solidFill>
           </a:ln>
           <a:effectLst/>
@@ -9755,7 +9755,7 @@
             <a:r>
               <a:rPr sz="1000" b="0">
                 <a:solidFill>
-                  <a:srgbClr val="5A7674"/>
+                  <a:srgbClr val="33555F"/>
                 </a:solidFill>
                 <a:latin typeface="Plus Jakarta Sans"/>
               </a:rPr>
@@ -9781,11 +9781,11 @@
             </a:avLst>
           </a:prstGeom>
           <a:solidFill>
-            <a:srgbClr val="F2F8F7"/>
+            <a:srgbClr val="F0F7F8"/>
           </a:solidFill>
           <a:ln w="12700">
             <a:solidFill>
-              <a:srgbClr val="DCEAE8"/>
+              <a:srgbClr val="DCEAED"/>
             </a:solidFill>
           </a:ln>
           <a:effectLst/>
@@ -9845,7 +9845,7 @@
             <a:r>
               <a:rPr sz="1000" b="0">
                 <a:solidFill>
-                  <a:srgbClr val="5A7674"/>
+                  <a:srgbClr val="33555F"/>
                 </a:solidFill>
                 <a:latin typeface="Plus Jakarta Sans"/>
               </a:rPr>
@@ -9871,11 +9871,11 @@
             </a:avLst>
           </a:prstGeom>
           <a:solidFill>
-            <a:srgbClr val="F2F8F7"/>
+            <a:srgbClr val="F0F7F8"/>
           </a:solidFill>
           <a:ln w="12700">
             <a:solidFill>
-              <a:srgbClr val="DCEAE8"/>
+              <a:srgbClr val="DCEAED"/>
             </a:solidFill>
           </a:ln>
           <a:effectLst/>
@@ -9935,7 +9935,7 @@
             <a:r>
               <a:rPr sz="1000" b="0">
                 <a:solidFill>
-                  <a:srgbClr val="5A7674"/>
+                  <a:srgbClr val="33555F"/>
                 </a:solidFill>
                 <a:latin typeface="Plus Jakarta Sans"/>
               </a:rPr>
@@ -9977,7 +9977,7 @@
             <a:r>
               <a:rPr sz="700" b="0" cap="all" spc="140">
                 <a:solidFill>
-                  <a:srgbClr val="8FA6A4"/>
+                  <a:srgbClr val="52737D"/>
                 </a:solidFill>
                 <a:latin typeface="IBM Plex Mono"/>
               </a:rPr>
@@ -10019,7 +10019,7 @@
             <a:r>
               <a:rPr sz="900" b="0">
                 <a:solidFill>
-                  <a:srgbClr val="8FA6A4"/>
+                  <a:srgbClr val="52737D"/>
                 </a:solidFill>
                 <a:latin typeface="IBM Plex Mono"/>
               </a:rPr>
@@ -10061,7 +10061,7 @@
             <a:avLst/>
           </a:prstGeom>
           <a:solidFill>
-            <a:srgbClr val="FFFFFF"/>
+            <a:srgbClr val="FBFDFE"/>
           </a:solidFill>
           <a:ln>
             <a:noFill/>
@@ -10123,7 +10123,7 @@
             <a:r>
               <a:rPr sz="1000" b="0" cap="all" spc="240">
                 <a:solidFill>
-                  <a:srgbClr val="B55615"/>
+                  <a:srgbClr val="8A6608"/>
                 </a:solidFill>
                 <a:latin typeface="IBM Plex Mono"/>
               </a:rPr>
@@ -10165,7 +10165,7 @@
             <a:r>
               <a:rPr sz="3000" b="1">
                 <a:solidFill>
-                  <a:srgbClr val="17302E"/>
+                  <a:srgbClr val="0E2830"/>
                 </a:solidFill>
                 <a:latin typeface="Outfit"/>
               </a:rPr>
@@ -10191,11 +10191,11 @@
             </a:avLst>
           </a:prstGeom>
           <a:solidFill>
-            <a:srgbClr val="0A4B49"/>
+            <a:srgbClr val="0A5F65"/>
           </a:solidFill>
           <a:ln w="12700">
             <a:solidFill>
-              <a:srgbClr val="0A4B49"/>
+              <a:srgbClr val="0A5F65"/>
             </a:solidFill>
           </a:ln>
           <a:effectLst/>
@@ -10279,7 +10279,7 @@
             <a:avLst/>
           </a:prstGeom>
           <a:solidFill>
-            <a:srgbClr val="E8823D"/>
+            <a:srgbClr val="E9B949"/>
           </a:solidFill>
           <a:ln>
             <a:noFill/>
@@ -10341,7 +10341,7 @@
             <a:r>
               <a:rPr sz="980" b="0">
                 <a:solidFill>
-                  <a:srgbClr val="D3E8E6"/>
+                  <a:srgbClr val="DCF2F3"/>
                 </a:solidFill>
                 <a:latin typeface="Plus Jakarta Sans"/>
               </a:rPr>
@@ -10365,7 +10365,7 @@
             <a:avLst/>
           </a:prstGeom>
           <a:solidFill>
-            <a:srgbClr val="E8823D"/>
+            <a:srgbClr val="E9B949"/>
           </a:solidFill>
           <a:ln>
             <a:noFill/>
@@ -10427,7 +10427,7 @@
             <a:r>
               <a:rPr sz="980" b="0">
                 <a:solidFill>
-                  <a:srgbClr val="D3E8E6"/>
+                  <a:srgbClr val="DCF2F3"/>
                 </a:solidFill>
                 <a:latin typeface="Plus Jakarta Sans"/>
               </a:rPr>
@@ -10451,7 +10451,7 @@
             <a:avLst/>
           </a:prstGeom>
           <a:solidFill>
-            <a:srgbClr val="E8823D"/>
+            <a:srgbClr val="E9B949"/>
           </a:solidFill>
           <a:ln>
             <a:noFill/>
@@ -10513,7 +10513,7 @@
             <a:r>
               <a:rPr sz="980" b="0">
                 <a:solidFill>
-                  <a:srgbClr val="D3E8E6"/>
+                  <a:srgbClr val="DCF2F3"/>
                 </a:solidFill>
                 <a:latin typeface="Plus Jakarta Sans"/>
               </a:rPr>
@@ -10537,7 +10537,7 @@
             <a:avLst/>
           </a:prstGeom>
           <a:solidFill>
-            <a:srgbClr val="E8823D"/>
+            <a:srgbClr val="E9B949"/>
           </a:solidFill>
           <a:ln>
             <a:noFill/>
@@ -10599,7 +10599,7 @@
             <a:r>
               <a:rPr sz="980" b="0">
                 <a:solidFill>
-                  <a:srgbClr val="D3E8E6"/>
+                  <a:srgbClr val="DCF2F3"/>
                 </a:solidFill>
                 <a:latin typeface="Plus Jakarta Sans"/>
               </a:rPr>
@@ -10625,11 +10625,11 @@
             </a:avLst>
           </a:prstGeom>
           <a:solidFill>
-            <a:srgbClr val="13807C"/>
+            <a:srgbClr val="0C7A80"/>
           </a:solidFill>
           <a:ln w="12700">
             <a:solidFill>
-              <a:srgbClr val="13807C"/>
+              <a:srgbClr val="0C7A80"/>
             </a:solidFill>
           </a:ln>
           <a:effectLst/>
@@ -10713,7 +10713,7 @@
             <a:avLst/>
           </a:prstGeom>
           <a:solidFill>
-            <a:srgbClr val="E8823D"/>
+            <a:srgbClr val="FFD264"/>
           </a:solidFill>
           <a:ln>
             <a:noFill/>
@@ -10799,7 +10799,7 @@
             <a:avLst/>
           </a:prstGeom>
           <a:solidFill>
-            <a:srgbClr val="E8823D"/>
+            <a:srgbClr val="FFD264"/>
           </a:solidFill>
           <a:ln>
             <a:noFill/>
@@ -10885,7 +10885,7 @@
             <a:avLst/>
           </a:prstGeom>
           <a:solidFill>
-            <a:srgbClr val="E8823D"/>
+            <a:srgbClr val="FFD264"/>
           </a:solidFill>
           <a:ln>
             <a:noFill/>
@@ -10973,11 +10973,11 @@
             </a:avLst>
           </a:prstGeom>
           <a:solidFill>
-            <a:srgbClr val="F2F8F7"/>
+            <a:srgbClr val="F0F7F8"/>
           </a:solidFill>
           <a:ln w="12700">
             <a:solidFill>
-              <a:srgbClr val="DCEAE8"/>
+              <a:srgbClr val="DCEAED"/>
             </a:solidFill>
           </a:ln>
           <a:effectLst/>
@@ -11037,7 +11037,7 @@
             <a:r>
               <a:rPr sz="1200" b="1">
                 <a:solidFill>
-                  <a:srgbClr val="17302E"/>
+                  <a:srgbClr val="0E2830"/>
                 </a:solidFill>
                 <a:latin typeface="Outfit"/>
               </a:rPr>
@@ -11061,7 +11061,7 @@
             <a:avLst/>
           </a:prstGeom>
           <a:solidFill>
-            <a:srgbClr val="0E6B68"/>
+            <a:srgbClr val="E9B949"/>
           </a:solidFill>
           <a:ln>
             <a:noFill/>
@@ -11123,7 +11123,7 @@
             <a:r>
               <a:rPr sz="980" b="0">
                 <a:solidFill>
-                  <a:srgbClr val="5A7674"/>
+                  <a:srgbClr val="33555F"/>
                 </a:solidFill>
                 <a:latin typeface="Plus Jakarta Sans"/>
               </a:rPr>
@@ -11147,7 +11147,7 @@
             <a:avLst/>
           </a:prstGeom>
           <a:solidFill>
-            <a:srgbClr val="0E6B68"/>
+            <a:srgbClr val="E9B949"/>
           </a:solidFill>
           <a:ln>
             <a:noFill/>
@@ -11209,7 +11209,7 @@
             <a:r>
               <a:rPr sz="980" b="0">
                 <a:solidFill>
-                  <a:srgbClr val="5A7674"/>
+                  <a:srgbClr val="33555F"/>
                 </a:solidFill>
                 <a:latin typeface="Plus Jakarta Sans"/>
               </a:rPr>
@@ -11233,7 +11233,7 @@
             <a:avLst/>
           </a:prstGeom>
           <a:solidFill>
-            <a:srgbClr val="0E6B68"/>
+            <a:srgbClr val="E9B949"/>
           </a:solidFill>
           <a:ln>
             <a:noFill/>
@@ -11295,7 +11295,7 @@
             <a:r>
               <a:rPr sz="980" b="0">
                 <a:solidFill>
-                  <a:srgbClr val="5A7674"/>
+                  <a:srgbClr val="33555F"/>
                 </a:solidFill>
                 <a:latin typeface="Plus Jakarta Sans"/>
               </a:rPr>
@@ -11321,11 +11321,11 @@
             </a:avLst>
           </a:prstGeom>
           <a:solidFill>
-            <a:srgbClr val="F2F8F7"/>
+            <a:srgbClr val="F0F7F8"/>
           </a:solidFill>
           <a:ln w="12700">
             <a:solidFill>
-              <a:srgbClr val="DCEAE8"/>
+              <a:srgbClr val="DCEAED"/>
             </a:solidFill>
           </a:ln>
           <a:effectLst/>
@@ -11385,7 +11385,7 @@
             <a:r>
               <a:rPr sz="1200" b="1">
                 <a:solidFill>
-                  <a:srgbClr val="17302E"/>
+                  <a:srgbClr val="0E2830"/>
                 </a:solidFill>
                 <a:latin typeface="Outfit"/>
               </a:rPr>
@@ -11409,7 +11409,7 @@
             <a:avLst/>
           </a:prstGeom>
           <a:solidFill>
-            <a:srgbClr val="0E6B68"/>
+            <a:srgbClr val="E9B949"/>
           </a:solidFill>
           <a:ln>
             <a:noFill/>
@@ -11471,7 +11471,7 @@
             <a:r>
               <a:rPr sz="980" b="0">
                 <a:solidFill>
-                  <a:srgbClr val="5A7674"/>
+                  <a:srgbClr val="33555F"/>
                 </a:solidFill>
                 <a:latin typeface="Plus Jakarta Sans"/>
               </a:rPr>
@@ -11495,7 +11495,7 @@
             <a:avLst/>
           </a:prstGeom>
           <a:solidFill>
-            <a:srgbClr val="0E6B68"/>
+            <a:srgbClr val="E9B949"/>
           </a:solidFill>
           <a:ln>
             <a:noFill/>
@@ -11557,7 +11557,7 @@
             <a:r>
               <a:rPr sz="980" b="0">
                 <a:solidFill>
-                  <a:srgbClr val="5A7674"/>
+                  <a:srgbClr val="33555F"/>
                 </a:solidFill>
                 <a:latin typeface="Plus Jakarta Sans"/>
               </a:rPr>
@@ -11599,7 +11599,7 @@
             <a:r>
               <a:rPr sz="700" b="0" cap="all" spc="140">
                 <a:solidFill>
-                  <a:srgbClr val="8FA6A4"/>
+                  <a:srgbClr val="52737D"/>
                 </a:solidFill>
                 <a:latin typeface="IBM Plex Mono"/>
               </a:rPr>
@@ -11641,7 +11641,7 @@
             <a:r>
               <a:rPr sz="900" b="0">
                 <a:solidFill>
-                  <a:srgbClr val="8FA6A4"/>
+                  <a:srgbClr val="52737D"/>
                 </a:solidFill>
                 <a:latin typeface="IBM Plex Mono"/>
               </a:rPr>
@@ -11683,7 +11683,7 @@
             <a:avLst/>
           </a:prstGeom>
           <a:solidFill>
-            <a:srgbClr val="FFFFFF"/>
+            <a:srgbClr val="FBFDFE"/>
           </a:solidFill>
           <a:ln>
             <a:noFill/>
@@ -11745,7 +11745,7 @@
             <a:r>
               <a:rPr sz="1000" b="0" cap="all" spc="240">
                 <a:solidFill>
-                  <a:srgbClr val="B55615"/>
+                  <a:srgbClr val="8A6608"/>
                 </a:solidFill>
                 <a:latin typeface="IBM Plex Mono"/>
               </a:rPr>
@@ -11787,7 +11787,7 @@
             <a:r>
               <a:rPr sz="3000" b="1">
                 <a:solidFill>
-                  <a:srgbClr val="17302E"/>
+                  <a:srgbClr val="0E2830"/>
                 </a:solidFill>
                 <a:latin typeface="Outfit"/>
               </a:rPr>
@@ -11813,11 +11813,11 @@
             </a:avLst>
           </a:prstGeom>
           <a:solidFill>
-            <a:srgbClr val="0A4B49"/>
+            <a:srgbClr val="0A5F65"/>
           </a:solidFill>
           <a:ln w="12700">
             <a:solidFill>
-              <a:srgbClr val="0A4B49"/>
+              <a:srgbClr val="0A5F65"/>
             </a:solidFill>
           </a:ln>
           <a:effectLst/>
@@ -11877,7 +11877,7 @@
             <a:r>
               <a:rPr sz="800" b="0" cap="all" spc="180">
                 <a:solidFill>
-                  <a:srgbClr val="9DC4C1"/>
+                  <a:srgbClr val="A9D6D9"/>
                 </a:solidFill>
                 <a:latin typeface="IBM Plex Mono"/>
               </a:rPr>
@@ -11943,7 +11943,7 @@
             <a:avLst/>
           </a:prstGeom>
           <a:solidFill>
-            <a:srgbClr val="E8823D"/>
+            <a:srgbClr val="E9B949"/>
           </a:solidFill>
           <a:ln>
             <a:noFill/>
@@ -12005,7 +12005,7 @@
             <a:r>
               <a:rPr sz="919" b="0">
                 <a:solidFill>
-                  <a:srgbClr val="D3E8E6"/>
+                  <a:srgbClr val="DCF2F3"/>
                 </a:solidFill>
                 <a:latin typeface="Plus Jakarta Sans"/>
               </a:rPr>
@@ -12029,7 +12029,7 @@
             <a:avLst/>
           </a:prstGeom>
           <a:solidFill>
-            <a:srgbClr val="E8823D"/>
+            <a:srgbClr val="E9B949"/>
           </a:solidFill>
           <a:ln>
             <a:noFill/>
@@ -12091,7 +12091,7 @@
             <a:r>
               <a:rPr sz="919" b="0">
                 <a:solidFill>
-                  <a:srgbClr val="D3E8E6"/>
+                  <a:srgbClr val="DCF2F3"/>
                 </a:solidFill>
                 <a:latin typeface="Plus Jakarta Sans"/>
               </a:rPr>
@@ -12115,7 +12115,7 @@
             <a:avLst/>
           </a:prstGeom>
           <a:solidFill>
-            <a:srgbClr val="E8823D"/>
+            <a:srgbClr val="E9B949"/>
           </a:solidFill>
           <a:ln>
             <a:noFill/>
@@ -12177,7 +12177,7 @@
             <a:r>
               <a:rPr sz="919" b="0">
                 <a:solidFill>
-                  <a:srgbClr val="D3E8E6"/>
+                  <a:srgbClr val="DCF2F3"/>
                 </a:solidFill>
                 <a:latin typeface="Plus Jakarta Sans"/>
               </a:rPr>
@@ -12203,11 +12203,11 @@
             </a:avLst>
           </a:prstGeom>
           <a:solidFill>
-            <a:srgbClr val="13807C"/>
+            <a:srgbClr val="0C7A80"/>
           </a:solidFill>
           <a:ln w="12700">
             <a:solidFill>
-              <a:srgbClr val="13807C"/>
+              <a:srgbClr val="0C7A80"/>
             </a:solidFill>
           </a:ln>
           <a:effectLst/>
@@ -12333,7 +12333,7 @@
             <a:avLst/>
           </a:prstGeom>
           <a:solidFill>
-            <a:srgbClr val="E8823D"/>
+            <a:srgbClr val="FFD264"/>
           </a:solidFill>
           <a:ln>
             <a:noFill/>
@@ -12419,7 +12419,7 @@
             <a:avLst/>
           </a:prstGeom>
           <a:solidFill>
-            <a:srgbClr val="E8823D"/>
+            <a:srgbClr val="FFD264"/>
           </a:solidFill>
           <a:ln>
             <a:noFill/>
@@ -12505,7 +12505,7 @@
             <a:avLst/>
           </a:prstGeom>
           <a:solidFill>
-            <a:srgbClr val="E8823D"/>
+            <a:srgbClr val="FFD264"/>
           </a:solidFill>
           <a:ln>
             <a:noFill/>
@@ -12593,11 +12593,11 @@
             </a:avLst>
           </a:prstGeom>
           <a:solidFill>
-            <a:srgbClr val="FBDCE6"/>
+            <a:srgbClr val="FCE2F0"/>
           </a:solidFill>
           <a:ln w="12700">
             <a:solidFill>
-              <a:srgbClr val="E85C82"/>
+              <a:srgbClr val="F49CCB"/>
             </a:solidFill>
           </a:ln>
           <a:effectLst/>
@@ -12657,7 +12657,7 @@
             <a:r>
               <a:rPr sz="800" b="0" cap="all" spc="180">
                 <a:solidFill>
-                  <a:srgbClr val="C11B48"/>
+                  <a:srgbClr val="C10073"/>
                 </a:solidFill>
                 <a:latin typeface="IBM Plex Mono"/>
               </a:rPr>
@@ -12699,7 +12699,7 @@
             <a:r>
               <a:rPr sz="1150" b="1">
                 <a:solidFill>
-                  <a:srgbClr val="17302E"/>
+                  <a:srgbClr val="0E2830"/>
                 </a:solidFill>
                 <a:latin typeface="Outfit"/>
               </a:rPr>
@@ -12723,7 +12723,7 @@
             <a:avLst/>
           </a:prstGeom>
           <a:solidFill>
-            <a:srgbClr val="E85C82"/>
+            <a:srgbClr val="EC008C"/>
           </a:solidFill>
           <a:ln>
             <a:noFill/>
@@ -12785,7 +12785,7 @@
             <a:r>
               <a:rPr sz="919" b="0">
                 <a:solidFill>
-                  <a:srgbClr val="17302E"/>
+                  <a:srgbClr val="33555F"/>
                 </a:solidFill>
                 <a:latin typeface="Plus Jakarta Sans"/>
               </a:rPr>
@@ -12809,7 +12809,7 @@
             <a:avLst/>
           </a:prstGeom>
           <a:solidFill>
-            <a:srgbClr val="E85C82"/>
+            <a:srgbClr val="EC008C"/>
           </a:solidFill>
           <a:ln>
             <a:noFill/>
@@ -12871,7 +12871,7 @@
             <a:r>
               <a:rPr sz="919" b="0">
                 <a:solidFill>
-                  <a:srgbClr val="17302E"/>
+                  <a:srgbClr val="33555F"/>
                 </a:solidFill>
                 <a:latin typeface="Plus Jakarta Sans"/>
               </a:rPr>
@@ -12895,7 +12895,7 @@
             <a:avLst/>
           </a:prstGeom>
           <a:solidFill>
-            <a:srgbClr val="E85C82"/>
+            <a:srgbClr val="EC008C"/>
           </a:solidFill>
           <a:ln>
             <a:noFill/>
@@ -12957,7 +12957,7 @@
             <a:r>
               <a:rPr sz="919" b="0">
                 <a:solidFill>
-                  <a:srgbClr val="17302E"/>
+                  <a:srgbClr val="33555F"/>
                 </a:solidFill>
                 <a:latin typeface="Plus Jakarta Sans"/>
               </a:rPr>
@@ -12983,11 +12983,11 @@
             </a:avLst>
           </a:prstGeom>
           <a:solidFill>
-            <a:srgbClr val="E8823D"/>
+            <a:srgbClr val="FBF1D6"/>
           </a:solidFill>
           <a:ln w="12700">
             <a:solidFill>
-              <a:srgbClr val="E8823D"/>
+              <a:srgbClr val="D8AE55"/>
             </a:solidFill>
           </a:ln>
           <a:effectLst/>
@@ -13047,7 +13047,7 @@
             <a:r>
               <a:rPr sz="800" b="0" cap="all" spc="180">
                 <a:solidFill>
-                  <a:srgbClr val="451F04"/>
+                  <a:srgbClr val="8A6608"/>
                 </a:solidFill>
                 <a:latin typeface="IBM Plex Mono"/>
               </a:rPr>
@@ -13089,7 +13089,7 @@
             <a:r>
               <a:rPr sz="1150" b="1">
                 <a:solidFill>
-                  <a:srgbClr val="17302E"/>
+                  <a:srgbClr val="0E2830"/>
                 </a:solidFill>
                 <a:latin typeface="Outfit"/>
               </a:rPr>
@@ -13113,7 +13113,7 @@
             <a:avLst/>
           </a:prstGeom>
           <a:solidFill>
-            <a:srgbClr val="17302E"/>
+            <a:srgbClr val="E9B949"/>
           </a:solidFill>
           <a:ln>
             <a:noFill/>
@@ -13175,7 +13175,7 @@
             <a:r>
               <a:rPr sz="919" b="0">
                 <a:solidFill>
-                  <a:srgbClr val="17302E"/>
+                  <a:srgbClr val="33555F"/>
                 </a:solidFill>
                 <a:latin typeface="Plus Jakarta Sans"/>
               </a:rPr>
@@ -13199,7 +13199,7 @@
             <a:avLst/>
           </a:prstGeom>
           <a:solidFill>
-            <a:srgbClr val="17302E"/>
+            <a:srgbClr val="E9B949"/>
           </a:solidFill>
           <a:ln>
             <a:noFill/>
@@ -13261,7 +13261,7 @@
             <a:r>
               <a:rPr sz="919" b="0">
                 <a:solidFill>
-                  <a:srgbClr val="17302E"/>
+                  <a:srgbClr val="33555F"/>
                 </a:solidFill>
                 <a:latin typeface="Plus Jakarta Sans"/>
               </a:rPr>
@@ -13285,7 +13285,7 @@
             <a:avLst/>
           </a:prstGeom>
           <a:solidFill>
-            <a:srgbClr val="17302E"/>
+            <a:srgbClr val="E9B949"/>
           </a:solidFill>
           <a:ln>
             <a:noFill/>
@@ -13347,7 +13347,7 @@
             <a:r>
               <a:rPr sz="919" b="0">
                 <a:solidFill>
-                  <a:srgbClr val="17302E"/>
+                  <a:srgbClr val="33555F"/>
                 </a:solidFill>
                 <a:latin typeface="Plus Jakarta Sans"/>
               </a:rPr>
@@ -13389,7 +13389,7 @@
             <a:r>
               <a:rPr sz="700" b="0" cap="all" spc="140">
                 <a:solidFill>
-                  <a:srgbClr val="8FA6A4"/>
+                  <a:srgbClr val="52737D"/>
                 </a:solidFill>
                 <a:latin typeface="IBM Plex Mono"/>
               </a:rPr>
@@ -13431,7 +13431,7 @@
             <a:r>
               <a:rPr sz="900" b="0">
                 <a:solidFill>
-                  <a:srgbClr val="8FA6A4"/>
+                  <a:srgbClr val="52737D"/>
                 </a:solidFill>
                 <a:latin typeface="IBM Plex Mono"/>
               </a:rPr>
@@ -13473,7 +13473,7 @@
             <a:avLst/>
           </a:prstGeom>
           <a:solidFill>
-            <a:srgbClr val="0A4B49"/>
+            <a:srgbClr val="0A5F65"/>
           </a:solidFill>
           <a:ln>
             <a:noFill/>
@@ -13559,7 +13559,7 @@
             <a:r>
               <a:rPr sz="1050" b="0" cap="all" spc="260">
                 <a:solidFill>
-                  <a:srgbClr val="ED9D67"/>
+                  <a:srgbClr val="FFD264"/>
                 </a:solidFill>
                 <a:latin typeface="IBM Plex Mono"/>
               </a:rPr>
@@ -13601,7 +13601,7 @@
             <a:r>
               <a:rPr sz="4400" b="1">
                 <a:solidFill>
-                  <a:srgbClr val="E8823D"/>
+                  <a:srgbClr val="FFD264"/>
                 </a:solidFill>
                 <a:latin typeface="Outfit"/>
               </a:rPr>
@@ -13643,7 +13643,7 @@
             <a:r>
               <a:rPr sz="1150" b="0">
                 <a:solidFill>
-                  <a:srgbClr val="D3E8E6"/>
+                  <a:srgbClr val="DCF2F3"/>
                 </a:solidFill>
                 <a:latin typeface="Plus Jakarta Sans"/>
               </a:rPr>
@@ -13669,11 +13669,11 @@
             </a:avLst>
           </a:prstGeom>
           <a:solidFill>
-            <a:srgbClr val="13807C"/>
+            <a:srgbClr val="0C7A80"/>
           </a:solidFill>
           <a:ln w="12700">
             <a:solidFill>
-              <a:srgbClr val="13807C"/>
+              <a:srgbClr val="0C7A80"/>
             </a:solidFill>
           </a:ln>
           <a:effectLst/>
@@ -13776,7 +13776,7 @@
             <a:avLst/>
           </a:prstGeom>
           <a:solidFill>
-            <a:srgbClr val="2E7E7A"/>
+            <a:srgbClr val="2E8A90"/>
           </a:solidFill>
           <a:ln>
             <a:noFill/>
@@ -13862,7 +13862,7 @@
             <a:r>
               <a:rPr sz="800" b="0" cap="all" spc="180">
                 <a:solidFill>
-                  <a:srgbClr val="9DC4C1"/>
+                  <a:srgbClr val="A9D6D9"/>
                 </a:solidFill>
                 <a:latin typeface="IBM Plex Mono"/>
               </a:rPr>
@@ -13952,7 +13952,7 @@
             <a:r>
               <a:rPr sz="750" b="0" cap="all" spc="160">
                 <a:solidFill>
-                  <a:srgbClr val="9DC4C1"/>
+                  <a:srgbClr val="A9D6D9"/>
                 </a:solidFill>
                 <a:latin typeface="IBM Plex Mono"/>
               </a:rPr>
@@ -13994,7 +13994,7 @@
             <a:r>
               <a:rPr sz="900" b="0">
                 <a:solidFill>
-                  <a:srgbClr val="8FA6A4"/>
+                  <a:srgbClr val="A9D6D9"/>
                 </a:solidFill>
                 <a:latin typeface="IBM Plex Mono"/>
               </a:rPr>
@@ -14036,7 +14036,7 @@
             <a:avLst/>
           </a:prstGeom>
           <a:solidFill>
-            <a:srgbClr val="FFFFFF"/>
+            <a:srgbClr val="FBFDFE"/>
           </a:solidFill>
           <a:ln>
             <a:noFill/>
@@ -14098,7 +14098,7 @@
             <a:r>
               <a:rPr sz="1000" b="0" cap="all" spc="240">
                 <a:solidFill>
-                  <a:srgbClr val="B55615"/>
+                  <a:srgbClr val="8A6608"/>
                 </a:solidFill>
                 <a:latin typeface="IBM Plex Mono"/>
               </a:rPr>
@@ -14140,7 +14140,7 @@
             <a:r>
               <a:rPr sz="3000" b="1">
                 <a:solidFill>
-                  <a:srgbClr val="17302E"/>
+                  <a:srgbClr val="0E2830"/>
                 </a:solidFill>
                 <a:latin typeface="Outfit"/>
               </a:rPr>
@@ -14182,7 +14182,7 @@
             <a:r>
               <a:rPr sz="1200" b="0">
                 <a:solidFill>
-                  <a:srgbClr val="5A7674"/>
+                  <a:srgbClr val="52737D"/>
                 </a:solidFill>
                 <a:latin typeface="Plus Jakarta Sans"/>
               </a:rPr>
@@ -14208,11 +14208,11 @@
             </a:avLst>
           </a:prstGeom>
           <a:solidFill>
-            <a:srgbClr val="F2F8F7"/>
+            <a:srgbClr val="F0F7F8"/>
           </a:solidFill>
           <a:ln w="12700">
             <a:solidFill>
-              <a:srgbClr val="DCEAE8"/>
+              <a:srgbClr val="DCEAED"/>
             </a:solidFill>
           </a:ln>
           <a:effectLst/>
@@ -14272,7 +14272,7 @@
             <a:r>
               <a:rPr sz="800" b="0" cap="all" spc="180">
                 <a:solidFill>
-                  <a:srgbClr val="5D7573"/>
+                  <a:srgbClr val="52737D"/>
                 </a:solidFill>
                 <a:latin typeface="IBM Plex Mono"/>
               </a:rPr>
@@ -14291,7 +14291,7 @@
             <a:r>
               <a:rPr sz="1350" b="1">
                 <a:solidFill>
-                  <a:srgbClr val="17302E"/>
+                  <a:srgbClr val="0E2830"/>
                 </a:solidFill>
                 <a:latin typeface="Outfit"/>
               </a:rPr>
@@ -14310,7 +14310,7 @@
             <a:r>
               <a:rPr sz="1050" b="0">
                 <a:solidFill>
-                  <a:srgbClr val="5A7674"/>
+                  <a:srgbClr val="33555F"/>
                 </a:solidFill>
                 <a:latin typeface="Plus Jakarta Sans"/>
               </a:rPr>
@@ -14336,11 +14336,11 @@
             </a:avLst>
           </a:prstGeom>
           <a:solidFill>
-            <a:srgbClr val="F2F8F7"/>
+            <a:srgbClr val="F0F7F8"/>
           </a:solidFill>
           <a:ln w="12700">
             <a:solidFill>
-              <a:srgbClr val="DCEAE8"/>
+              <a:srgbClr val="DCEAED"/>
             </a:solidFill>
           </a:ln>
           <a:effectLst/>
@@ -14400,7 +14400,7 @@
             <a:r>
               <a:rPr sz="800" b="0" cap="all" spc="180">
                 <a:solidFill>
-                  <a:srgbClr val="5D7573"/>
+                  <a:srgbClr val="52737D"/>
                 </a:solidFill>
                 <a:latin typeface="IBM Plex Mono"/>
               </a:rPr>
@@ -14419,7 +14419,7 @@
             <a:r>
               <a:rPr sz="1350" b="1">
                 <a:solidFill>
-                  <a:srgbClr val="17302E"/>
+                  <a:srgbClr val="0E2830"/>
                 </a:solidFill>
                 <a:latin typeface="Outfit"/>
               </a:rPr>
@@ -14438,7 +14438,7 @@
             <a:r>
               <a:rPr sz="1050" b="0">
                 <a:solidFill>
-                  <a:srgbClr val="5A7674"/>
+                  <a:srgbClr val="33555F"/>
                 </a:solidFill>
                 <a:latin typeface="Plus Jakarta Sans"/>
               </a:rPr>
@@ -14464,11 +14464,11 @@
             </a:avLst>
           </a:prstGeom>
           <a:solidFill>
-            <a:srgbClr val="F2F8F7"/>
+            <a:srgbClr val="F0F7F8"/>
           </a:solidFill>
           <a:ln w="12700">
             <a:solidFill>
-              <a:srgbClr val="DCEAE8"/>
+              <a:srgbClr val="DCEAED"/>
             </a:solidFill>
           </a:ln>
           <a:effectLst/>
@@ -14528,7 +14528,7 @@
             <a:r>
               <a:rPr sz="800" b="0" cap="all" spc="180">
                 <a:solidFill>
-                  <a:srgbClr val="5D7573"/>
+                  <a:srgbClr val="52737D"/>
                 </a:solidFill>
                 <a:latin typeface="IBM Plex Mono"/>
               </a:rPr>
@@ -14547,7 +14547,7 @@
             <a:r>
               <a:rPr sz="1350" b="1">
                 <a:solidFill>
-                  <a:srgbClr val="17302E"/>
+                  <a:srgbClr val="0E2830"/>
                 </a:solidFill>
                 <a:latin typeface="Outfit"/>
               </a:rPr>
@@ -14566,7 +14566,7 @@
             <a:r>
               <a:rPr sz="1050" b="0">
                 <a:solidFill>
-                  <a:srgbClr val="5A7674"/>
+                  <a:srgbClr val="33555F"/>
                 </a:solidFill>
                 <a:latin typeface="Plus Jakarta Sans"/>
               </a:rPr>
@@ -14592,11 +14592,11 @@
             </a:avLst>
           </a:prstGeom>
           <a:solidFill>
-            <a:srgbClr val="F2F8F7"/>
+            <a:srgbClr val="F0F7F8"/>
           </a:solidFill>
           <a:ln w="12700">
             <a:solidFill>
-              <a:srgbClr val="DCEAE8"/>
+              <a:srgbClr val="DCEAED"/>
             </a:solidFill>
           </a:ln>
           <a:effectLst/>
@@ -14656,7 +14656,7 @@
             <a:r>
               <a:rPr sz="800" b="0" cap="all" spc="180">
                 <a:solidFill>
-                  <a:srgbClr val="5D7573"/>
+                  <a:srgbClr val="52737D"/>
                 </a:solidFill>
                 <a:latin typeface="IBM Plex Mono"/>
               </a:rPr>
@@ -14675,7 +14675,7 @@
             <a:r>
               <a:rPr sz="1350" b="1">
                 <a:solidFill>
-                  <a:srgbClr val="17302E"/>
+                  <a:srgbClr val="0E2830"/>
                 </a:solidFill>
                 <a:latin typeface="Outfit"/>
               </a:rPr>
@@ -14694,7 +14694,7 @@
             <a:r>
               <a:rPr sz="1050" b="0">
                 <a:solidFill>
-                  <a:srgbClr val="5A7674"/>
+                  <a:srgbClr val="33555F"/>
                 </a:solidFill>
                 <a:latin typeface="Plus Jakarta Sans"/>
               </a:rPr>
@@ -14736,7 +14736,7 @@
             <a:r>
               <a:rPr sz="700" b="0" cap="all" spc="140">
                 <a:solidFill>
-                  <a:srgbClr val="8FA6A4"/>
+                  <a:srgbClr val="52737D"/>
                 </a:solidFill>
                 <a:latin typeface="IBM Plex Mono"/>
               </a:rPr>
@@ -14778,7 +14778,7 @@
             <a:r>
               <a:rPr sz="900" b="0">
                 <a:solidFill>
-                  <a:srgbClr val="8FA6A4"/>
+                  <a:srgbClr val="52737D"/>
                 </a:solidFill>
                 <a:latin typeface="IBM Plex Mono"/>
               </a:rPr>
@@ -14820,7 +14820,7 @@
             <a:avLst/>
           </a:prstGeom>
           <a:solidFill>
-            <a:srgbClr val="FFFFFF"/>
+            <a:srgbClr val="FBFDFE"/>
           </a:solidFill>
           <a:ln>
             <a:noFill/>
@@ -14882,7 +14882,7 @@
             <a:r>
               <a:rPr sz="1000" b="0" cap="all" spc="240">
                 <a:solidFill>
-                  <a:srgbClr val="B55615"/>
+                  <a:srgbClr val="8A6608"/>
                 </a:solidFill>
                 <a:latin typeface="IBM Plex Mono"/>
               </a:rPr>
@@ -14924,7 +14924,7 @@
             <a:r>
               <a:rPr sz="3000" b="1">
                 <a:solidFill>
-                  <a:srgbClr val="17302E"/>
+                  <a:srgbClr val="0E2830"/>
                 </a:solidFill>
                 <a:latin typeface="Outfit"/>
               </a:rPr>
@@ -14948,7 +14948,7 @@
             <a:avLst/>
           </a:prstGeom>
           <a:solidFill>
-            <a:srgbClr val="0E6B68"/>
+            <a:srgbClr val="E9B949"/>
           </a:solidFill>
           <a:ln>
             <a:noFill/>
@@ -15010,7 +15010,7 @@
             <a:r>
               <a:rPr sz="1050" b="0">
                 <a:solidFill>
-                  <a:srgbClr val="5A7674"/>
+                  <a:srgbClr val="33555F"/>
                 </a:solidFill>
                 <a:latin typeface="Plus Jakarta Sans"/>
               </a:rPr>
@@ -15034,7 +15034,7 @@
             <a:avLst/>
           </a:prstGeom>
           <a:solidFill>
-            <a:srgbClr val="0E6B68"/>
+            <a:srgbClr val="E9B949"/>
           </a:solidFill>
           <a:ln>
             <a:noFill/>
@@ -15096,7 +15096,7 @@
             <a:r>
               <a:rPr sz="1050" b="0">
                 <a:solidFill>
-                  <a:srgbClr val="5A7674"/>
+                  <a:srgbClr val="33555F"/>
                 </a:solidFill>
                 <a:latin typeface="Plus Jakarta Sans"/>
               </a:rPr>
@@ -15120,7 +15120,7 @@
             <a:avLst/>
           </a:prstGeom>
           <a:solidFill>
-            <a:srgbClr val="0E6B68"/>
+            <a:srgbClr val="E9B949"/>
           </a:solidFill>
           <a:ln>
             <a:noFill/>
@@ -15182,7 +15182,7 @@
             <a:r>
               <a:rPr sz="1050" b="0">
                 <a:solidFill>
-                  <a:srgbClr val="5A7674"/>
+                  <a:srgbClr val="33555F"/>
                 </a:solidFill>
                 <a:latin typeface="Plus Jakarta Sans"/>
               </a:rPr>
@@ -15206,7 +15206,7 @@
             <a:avLst/>
           </a:prstGeom>
           <a:solidFill>
-            <a:srgbClr val="0E6B68"/>
+            <a:srgbClr val="E9B949"/>
           </a:solidFill>
           <a:ln>
             <a:noFill/>
@@ -15268,7 +15268,7 @@
             <a:r>
               <a:rPr sz="1050" b="0">
                 <a:solidFill>
-                  <a:srgbClr val="5A7674"/>
+                  <a:srgbClr val="33555F"/>
                 </a:solidFill>
                 <a:latin typeface="Plus Jakarta Sans"/>
               </a:rPr>
@@ -15294,11 +15294,11 @@
             </a:avLst>
           </a:prstGeom>
           <a:solidFill>
-            <a:srgbClr val="0A4B49"/>
+            <a:srgbClr val="0A5F65"/>
           </a:solidFill>
           <a:ln w="12700">
             <a:solidFill>
-              <a:srgbClr val="0A4B49"/>
+              <a:srgbClr val="0A5F65"/>
             </a:solidFill>
           </a:ln>
           <a:effectLst/>
@@ -15358,7 +15358,7 @@
             <a:r>
               <a:rPr sz="800" b="0" cap="all" spc="180">
                 <a:solidFill>
-                  <a:srgbClr val="9DC4C1"/>
+                  <a:srgbClr val="A9D6D9"/>
                 </a:solidFill>
                 <a:latin typeface="IBM Plex Mono"/>
               </a:rPr>
@@ -15383,7 +15383,7 @@
           </a:prstGeom>
           <a:ln w="25400">
             <a:solidFill>
-              <a:srgbClr val="E8823D"/>
+              <a:srgbClr val="FFD264"/>
             </a:solidFill>
           </a:ln>
         </p:spPr>
@@ -15418,7 +15418,7 @@
           </a:prstGeom>
           <a:ln w="25400">
             <a:solidFill>
-              <a:srgbClr val="E85C82"/>
+              <a:srgbClr val="FFB3E0"/>
             </a:solidFill>
           </a:ln>
         </p:spPr>
@@ -15452,7 +15452,7 @@
             <a:avLst/>
           </a:prstGeom>
           <a:solidFill>
-            <a:srgbClr val="0A4B49"/>
+            <a:srgbClr val="0A5F65"/>
           </a:solidFill>
           <a:ln w="25400">
             <a:solidFill>
@@ -15535,7 +15535,7 @@
             <a:r>
               <a:rPr sz="700" b="0" cap="all" spc="110">
                 <a:solidFill>
-                  <a:srgbClr val="9DC4C1"/>
+                  <a:srgbClr val="DCF2F3"/>
                 </a:solidFill>
                 <a:latin typeface="IBM Plex Mono"/>
               </a:rPr>
@@ -15559,11 +15559,11 @@
             <a:avLst/>
           </a:prstGeom>
           <a:solidFill>
-            <a:srgbClr val="0A4B49"/>
+            <a:srgbClr val="0A5F65"/>
           </a:solidFill>
           <a:ln w="25400">
             <a:solidFill>
-              <a:srgbClr val="E8823D"/>
+              <a:srgbClr val="FFD264"/>
             </a:solidFill>
           </a:ln>
           <a:effectLst/>
@@ -15623,7 +15623,7 @@
             <a:r>
               <a:rPr sz="1200" b="1">
                 <a:solidFill>
-                  <a:srgbClr val="E8823D"/>
+                  <a:srgbClr val="FFD264"/>
                 </a:solidFill>
                 <a:latin typeface="Outfit"/>
               </a:rPr>
@@ -15642,7 +15642,7 @@
             <a:r>
               <a:rPr sz="700" b="0" cap="all" spc="110">
                 <a:solidFill>
-                  <a:srgbClr val="9DC4C1"/>
+                  <a:srgbClr val="DCF2F3"/>
                 </a:solidFill>
                 <a:latin typeface="IBM Plex Mono"/>
               </a:rPr>
@@ -15666,11 +15666,11 @@
             <a:avLst/>
           </a:prstGeom>
           <a:solidFill>
-            <a:srgbClr val="0A4B49"/>
+            <a:srgbClr val="0A5F65"/>
           </a:solidFill>
           <a:ln w="25400">
             <a:solidFill>
-              <a:srgbClr val="E85C82"/>
+              <a:srgbClr val="FFB3E0"/>
             </a:solidFill>
           </a:ln>
           <a:effectLst/>
@@ -15730,7 +15730,7 @@
             <a:r>
               <a:rPr sz="1200" b="1">
                 <a:solidFill>
-                  <a:srgbClr val="E85C82"/>
+                  <a:srgbClr val="FFB3E0"/>
                 </a:solidFill>
                 <a:latin typeface="Outfit"/>
               </a:rPr>
@@ -15749,7 +15749,7 @@
             <a:r>
               <a:rPr sz="700" b="0" cap="all" spc="110">
                 <a:solidFill>
-                  <a:srgbClr val="9DC4C1"/>
+                  <a:srgbClr val="DCF2F3"/>
                 </a:solidFill>
                 <a:latin typeface="IBM Plex Mono"/>
               </a:rPr>
@@ -15775,11 +15775,11 @@
             </a:avLst>
           </a:prstGeom>
           <a:solidFill>
-            <a:srgbClr val="13807C"/>
+            <a:srgbClr val="0C7A80"/>
           </a:solidFill>
           <a:ln w="12700">
             <a:solidFill>
-              <a:srgbClr val="13807C"/>
+              <a:srgbClr val="0C7A80"/>
             </a:solidFill>
           </a:ln>
           <a:effectLst/>
@@ -15903,11 +15903,11 @@
             </a:avLst>
           </a:prstGeom>
           <a:solidFill>
-            <a:srgbClr val="13807C"/>
+            <a:srgbClr val="0C7A80"/>
           </a:solidFill>
           <a:ln w="12700">
             <a:solidFill>
-              <a:srgbClr val="13807C"/>
+              <a:srgbClr val="0C7A80"/>
             </a:solidFill>
           </a:ln>
           <a:effectLst/>
@@ -16047,7 +16047,7 @@
             <a:r>
               <a:rPr sz="700" b="0" cap="all" spc="140">
                 <a:solidFill>
-                  <a:srgbClr val="8FA6A4"/>
+                  <a:srgbClr val="52737D"/>
                 </a:solidFill>
                 <a:latin typeface="IBM Plex Mono"/>
               </a:rPr>
@@ -16089,7 +16089,7 @@
             <a:r>
               <a:rPr sz="900" b="0">
                 <a:solidFill>
-                  <a:srgbClr val="8FA6A4"/>
+                  <a:srgbClr val="52737D"/>
                 </a:solidFill>
                 <a:latin typeface="IBM Plex Mono"/>
               </a:rPr>
@@ -16131,7 +16131,7 @@
             <a:avLst/>
           </a:prstGeom>
           <a:solidFill>
-            <a:srgbClr val="FFFFFF"/>
+            <a:srgbClr val="FBFDFE"/>
           </a:solidFill>
           <a:ln>
             <a:noFill/>
@@ -16193,7 +16193,7 @@
             <a:r>
               <a:rPr sz="1000" b="0" cap="all" spc="240">
                 <a:solidFill>
-                  <a:srgbClr val="B55615"/>
+                  <a:srgbClr val="8A6608"/>
                 </a:solidFill>
                 <a:latin typeface="IBM Plex Mono"/>
               </a:rPr>
@@ -16235,7 +16235,7 @@
             <a:r>
               <a:rPr sz="3000" b="1">
                 <a:solidFill>
-                  <a:srgbClr val="17302E"/>
+                  <a:srgbClr val="0E2830"/>
                 </a:solidFill>
                 <a:latin typeface="Outfit"/>
               </a:rPr>
@@ -16261,11 +16261,11 @@
             </a:avLst>
           </a:prstGeom>
           <a:solidFill>
-            <a:srgbClr val="F2F8F7"/>
+            <a:srgbClr val="F0F7F8"/>
           </a:solidFill>
           <a:ln w="12700">
             <a:solidFill>
-              <a:srgbClr val="DCEAE8"/>
+              <a:srgbClr val="DCEAED"/>
             </a:solidFill>
           </a:ln>
           <a:effectLst/>
@@ -16325,7 +16325,7 @@
             <a:r>
               <a:rPr sz="1150" b="1">
                 <a:solidFill>
-                  <a:srgbClr val="17302E"/>
+                  <a:srgbClr val="0E2830"/>
                 </a:solidFill>
                 <a:latin typeface="Outfit"/>
               </a:rPr>
@@ -16344,7 +16344,7 @@
             <a:r>
               <a:rPr sz="950" b="0">
                 <a:solidFill>
-                  <a:srgbClr val="5A7674"/>
+                  <a:srgbClr val="33555F"/>
                 </a:solidFill>
                 <a:latin typeface="Plus Jakarta Sans"/>
               </a:rPr>
@@ -16370,11 +16370,11 @@
             </a:avLst>
           </a:prstGeom>
           <a:solidFill>
-            <a:srgbClr val="F2F8F7"/>
+            <a:srgbClr val="F0F7F8"/>
           </a:solidFill>
           <a:ln w="12700">
             <a:solidFill>
-              <a:srgbClr val="DCEAE8"/>
+              <a:srgbClr val="DCEAED"/>
             </a:solidFill>
           </a:ln>
           <a:effectLst/>
@@ -16434,7 +16434,7 @@
             <a:r>
               <a:rPr sz="1150" b="1">
                 <a:solidFill>
-                  <a:srgbClr val="17302E"/>
+                  <a:srgbClr val="0E2830"/>
                 </a:solidFill>
                 <a:latin typeface="Outfit"/>
               </a:rPr>
@@ -16453,7 +16453,7 @@
             <a:r>
               <a:rPr sz="950" b="0">
                 <a:solidFill>
-                  <a:srgbClr val="5A7674"/>
+                  <a:srgbClr val="33555F"/>
                 </a:solidFill>
                 <a:latin typeface="Plus Jakarta Sans"/>
               </a:rPr>
@@ -16479,11 +16479,11 @@
             </a:avLst>
           </a:prstGeom>
           <a:solidFill>
-            <a:srgbClr val="F2F8F7"/>
+            <a:srgbClr val="F0F7F8"/>
           </a:solidFill>
           <a:ln w="12700">
             <a:solidFill>
-              <a:srgbClr val="DCEAE8"/>
+              <a:srgbClr val="DCEAED"/>
             </a:solidFill>
           </a:ln>
           <a:effectLst/>
@@ -16543,7 +16543,7 @@
             <a:r>
               <a:rPr sz="1150" b="1">
                 <a:solidFill>
-                  <a:srgbClr val="17302E"/>
+                  <a:srgbClr val="0E2830"/>
                 </a:solidFill>
                 <a:latin typeface="Outfit"/>
               </a:rPr>
@@ -16562,7 +16562,7 @@
             <a:r>
               <a:rPr sz="950" b="0">
                 <a:solidFill>
-                  <a:srgbClr val="5A7674"/>
+                  <a:srgbClr val="33555F"/>
                 </a:solidFill>
                 <a:latin typeface="Plus Jakarta Sans"/>
               </a:rPr>
@@ -16588,11 +16588,11 @@
             </a:avLst>
           </a:prstGeom>
           <a:solidFill>
-            <a:srgbClr val="FBDCE6"/>
+            <a:srgbClr val="FCE2F0"/>
           </a:solidFill>
           <a:ln w="12700">
             <a:solidFill>
-              <a:srgbClr val="E85C82"/>
+              <a:srgbClr val="F49CCB"/>
             </a:solidFill>
           </a:ln>
           <a:effectLst/>
@@ -16652,7 +16652,7 @@
             <a:r>
               <a:rPr sz="1150" b="1">
                 <a:solidFill>
-                  <a:srgbClr val="17302E"/>
+                  <a:srgbClr val="0E2830"/>
                 </a:solidFill>
                 <a:latin typeface="Outfit"/>
               </a:rPr>
@@ -16671,7 +16671,7 @@
             <a:r>
               <a:rPr sz="950" b="0">
                 <a:solidFill>
-                  <a:srgbClr val="17302E"/>
+                  <a:srgbClr val="33555F"/>
                 </a:solidFill>
                 <a:latin typeface="Plus Jakarta Sans"/>
               </a:rPr>
@@ -16697,11 +16697,11 @@
             </a:avLst>
           </a:prstGeom>
           <a:solidFill>
-            <a:srgbClr val="FBDCE6"/>
+            <a:srgbClr val="FCE2F0"/>
           </a:solidFill>
           <a:ln w="12700">
             <a:solidFill>
-              <a:srgbClr val="E85C82"/>
+              <a:srgbClr val="F49CCB"/>
             </a:solidFill>
           </a:ln>
           <a:effectLst/>
@@ -16761,7 +16761,7 @@
             <a:r>
               <a:rPr sz="1150" b="1">
                 <a:solidFill>
-                  <a:srgbClr val="17302E"/>
+                  <a:srgbClr val="0E2830"/>
                 </a:solidFill>
                 <a:latin typeface="Outfit"/>
               </a:rPr>
@@ -16780,7 +16780,7 @@
             <a:r>
               <a:rPr sz="950" b="0">
                 <a:solidFill>
-                  <a:srgbClr val="17302E"/>
+                  <a:srgbClr val="33555F"/>
                 </a:solidFill>
                 <a:latin typeface="Plus Jakarta Sans"/>
               </a:rPr>
@@ -16822,7 +16822,7 @@
             <a:r>
               <a:rPr sz="700" b="0" cap="all" spc="140">
                 <a:solidFill>
-                  <a:srgbClr val="8FA6A4"/>
+                  <a:srgbClr val="52737D"/>
                 </a:solidFill>
                 <a:latin typeface="IBM Plex Mono"/>
               </a:rPr>
@@ -16864,7 +16864,7 @@
             <a:r>
               <a:rPr sz="900" b="0">
                 <a:solidFill>
-                  <a:srgbClr val="8FA6A4"/>
+                  <a:srgbClr val="52737D"/>
                 </a:solidFill>
                 <a:latin typeface="IBM Plex Mono"/>
               </a:rPr>
@@ -16906,7 +16906,7 @@
             <a:avLst/>
           </a:prstGeom>
           <a:solidFill>
-            <a:srgbClr val="FFFFFF"/>
+            <a:srgbClr val="FBFDFE"/>
           </a:solidFill>
           <a:ln>
             <a:noFill/>
@@ -16968,7 +16968,7 @@
             <a:r>
               <a:rPr sz="1000" b="0" cap="all" spc="240">
                 <a:solidFill>
-                  <a:srgbClr val="B55615"/>
+                  <a:srgbClr val="8A6608"/>
                 </a:solidFill>
                 <a:latin typeface="IBM Plex Mono"/>
               </a:rPr>
@@ -17010,7 +17010,7 @@
             <a:r>
               <a:rPr sz="3000" b="1">
                 <a:solidFill>
-                  <a:srgbClr val="17302E"/>
+                  <a:srgbClr val="0E2830"/>
                 </a:solidFill>
                 <a:latin typeface="Outfit"/>
               </a:rPr>
@@ -17036,11 +17036,11 @@
             </a:avLst>
           </a:prstGeom>
           <a:solidFill>
-            <a:srgbClr val="F2F8F7"/>
+            <a:srgbClr val="F0F7F8"/>
           </a:solidFill>
           <a:ln w="12700">
             <a:solidFill>
-              <a:srgbClr val="DCEAE8"/>
+              <a:srgbClr val="DCEAED"/>
             </a:solidFill>
           </a:ln>
           <a:effectLst/>
@@ -17100,7 +17100,7 @@
             <a:r>
               <a:rPr sz="1100" b="1">
                 <a:solidFill>
-                  <a:srgbClr val="17302E"/>
+                  <a:srgbClr val="0E2830"/>
                 </a:solidFill>
                 <a:latin typeface="Outfit"/>
               </a:rPr>
@@ -17119,7 +17119,7 @@
             <a:r>
               <a:rPr sz="919" b="0">
                 <a:solidFill>
-                  <a:srgbClr val="5A7674"/>
+                  <a:srgbClr val="33555F"/>
                 </a:solidFill>
                 <a:latin typeface="Plus Jakarta Sans"/>
               </a:rPr>
@@ -17145,11 +17145,11 @@
             </a:avLst>
           </a:prstGeom>
           <a:solidFill>
-            <a:srgbClr val="F2F8F7"/>
+            <a:srgbClr val="F0F7F8"/>
           </a:solidFill>
           <a:ln w="12700">
             <a:solidFill>
-              <a:srgbClr val="DCEAE8"/>
+              <a:srgbClr val="DCEAED"/>
             </a:solidFill>
           </a:ln>
           <a:effectLst/>
@@ -17209,7 +17209,7 @@
             <a:r>
               <a:rPr sz="1100" b="1">
                 <a:solidFill>
-                  <a:srgbClr val="17302E"/>
+                  <a:srgbClr val="0E2830"/>
                 </a:solidFill>
                 <a:latin typeface="Outfit"/>
               </a:rPr>
@@ -17228,7 +17228,7 @@
             <a:r>
               <a:rPr sz="919" b="0">
                 <a:solidFill>
-                  <a:srgbClr val="5A7674"/>
+                  <a:srgbClr val="33555F"/>
                 </a:solidFill>
                 <a:latin typeface="Plus Jakarta Sans"/>
               </a:rPr>
@@ -17254,11 +17254,11 @@
             </a:avLst>
           </a:prstGeom>
           <a:solidFill>
-            <a:srgbClr val="F2F8F7"/>
+            <a:srgbClr val="F0F7F8"/>
           </a:solidFill>
           <a:ln w="12700">
             <a:solidFill>
-              <a:srgbClr val="DCEAE8"/>
+              <a:srgbClr val="DCEAED"/>
             </a:solidFill>
           </a:ln>
           <a:effectLst/>
@@ -17318,7 +17318,7 @@
             <a:r>
               <a:rPr sz="1100" b="1">
                 <a:solidFill>
-                  <a:srgbClr val="17302E"/>
+                  <a:srgbClr val="0E2830"/>
                 </a:solidFill>
                 <a:latin typeface="Outfit"/>
               </a:rPr>
@@ -17337,7 +17337,7 @@
             <a:r>
               <a:rPr sz="919" b="0">
                 <a:solidFill>
-                  <a:srgbClr val="5A7674"/>
+                  <a:srgbClr val="33555F"/>
                 </a:solidFill>
                 <a:latin typeface="Plus Jakarta Sans"/>
               </a:rPr>
@@ -17363,11 +17363,11 @@
             </a:avLst>
           </a:prstGeom>
           <a:solidFill>
-            <a:srgbClr val="F2F8F7"/>
+            <a:srgbClr val="F0F7F8"/>
           </a:solidFill>
           <a:ln w="12700">
             <a:solidFill>
-              <a:srgbClr val="DCEAE8"/>
+              <a:srgbClr val="DCEAED"/>
             </a:solidFill>
           </a:ln>
           <a:effectLst/>
@@ -17427,7 +17427,7 @@
             <a:r>
               <a:rPr sz="1100" b="1">
                 <a:solidFill>
-                  <a:srgbClr val="17302E"/>
+                  <a:srgbClr val="0E2830"/>
                 </a:solidFill>
                 <a:latin typeface="Outfit"/>
               </a:rPr>
@@ -17446,7 +17446,7 @@
             <a:r>
               <a:rPr sz="919" b="0">
                 <a:solidFill>
-                  <a:srgbClr val="5A7674"/>
+                  <a:srgbClr val="33555F"/>
                 </a:solidFill>
                 <a:latin typeface="Plus Jakarta Sans"/>
               </a:rPr>
@@ -17472,11 +17472,11 @@
             </a:avLst>
           </a:prstGeom>
           <a:solidFill>
-            <a:srgbClr val="E8823D"/>
+            <a:srgbClr val="FBF1D6"/>
           </a:solidFill>
           <a:ln w="12700">
             <a:solidFill>
-              <a:srgbClr val="E8823D"/>
+              <a:srgbClr val="D8AE55"/>
             </a:solidFill>
           </a:ln>
           <a:effectLst/>
@@ -17536,7 +17536,7 @@
             <a:r>
               <a:rPr sz="2400" b="1">
                 <a:solidFill>
-                  <a:srgbClr val="17302E"/>
+                  <a:srgbClr val="0E2830"/>
                 </a:solidFill>
                 <a:latin typeface="Outfit"/>
               </a:rPr>
@@ -17555,7 +17555,7 @@
             <a:r>
               <a:rPr sz="919" b="0">
                 <a:solidFill>
-                  <a:srgbClr val="17302E"/>
+                  <a:srgbClr val="33555F"/>
                 </a:solidFill>
                 <a:latin typeface="Plus Jakarta Sans"/>
               </a:rPr>
@@ -17581,11 +17581,11 @@
             </a:avLst>
           </a:prstGeom>
           <a:solidFill>
-            <a:srgbClr val="0A4B49"/>
+            <a:srgbClr val="0A5F65"/>
           </a:solidFill>
           <a:ln w="12700">
             <a:solidFill>
-              <a:srgbClr val="0A4B49"/>
+              <a:srgbClr val="0A5F65"/>
             </a:solidFill>
           </a:ln>
           <a:effectLst/>
@@ -17664,7 +17664,7 @@
             <a:r>
               <a:rPr sz="919" b="0">
                 <a:solidFill>
-                  <a:srgbClr val="D3E8E6"/>
+                  <a:srgbClr val="DCF2F3"/>
                 </a:solidFill>
                 <a:latin typeface="Plus Jakarta Sans"/>
               </a:rPr>
@@ -17706,7 +17706,7 @@
             <a:r>
               <a:rPr sz="700" b="0" cap="all" spc="140">
                 <a:solidFill>
-                  <a:srgbClr val="8FA6A4"/>
+                  <a:srgbClr val="52737D"/>
                 </a:solidFill>
                 <a:latin typeface="IBM Plex Mono"/>
               </a:rPr>
@@ -17748,7 +17748,7 @@
             <a:r>
               <a:rPr sz="900" b="0">
                 <a:solidFill>
-                  <a:srgbClr val="8FA6A4"/>
+                  <a:srgbClr val="52737D"/>
                 </a:solidFill>
                 <a:latin typeface="IBM Plex Mono"/>
               </a:rPr>
@@ -17790,7 +17790,7 @@
             <a:avLst/>
           </a:prstGeom>
           <a:solidFill>
-            <a:srgbClr val="FFFFFF"/>
+            <a:srgbClr val="FBFDFE"/>
           </a:solidFill>
           <a:ln>
             <a:noFill/>
@@ -17852,7 +17852,7 @@
             <a:r>
               <a:rPr sz="1000" b="0" cap="all" spc="240">
                 <a:solidFill>
-                  <a:srgbClr val="B55615"/>
+                  <a:srgbClr val="8A6608"/>
                 </a:solidFill>
                 <a:latin typeface="IBM Plex Mono"/>
               </a:rPr>
@@ -17894,7 +17894,7 @@
             <a:r>
               <a:rPr sz="3000" b="1">
                 <a:solidFill>
-                  <a:srgbClr val="17302E"/>
+                  <a:srgbClr val="0E2830"/>
                 </a:solidFill>
                 <a:latin typeface="Outfit"/>
               </a:rPr>
@@ -17920,11 +17920,11 @@
             </a:avLst>
           </a:prstGeom>
           <a:solidFill>
-            <a:srgbClr val="F2F8F7"/>
+            <a:srgbClr val="F0F7F8"/>
           </a:solidFill>
           <a:ln w="12700">
             <a:solidFill>
-              <a:srgbClr val="DCEAE8"/>
+              <a:srgbClr val="DCEAED"/>
             </a:solidFill>
           </a:ln>
           <a:effectLst/>
@@ -17984,7 +17984,7 @@
             <a:r>
               <a:rPr sz="1100" b="1">
                 <a:solidFill>
-                  <a:srgbClr val="17302E"/>
+                  <a:srgbClr val="0E2830"/>
                 </a:solidFill>
                 <a:latin typeface="Outfit"/>
               </a:rPr>
@@ -18003,7 +18003,7 @@
             <a:r>
               <a:rPr sz="919" b="0">
                 <a:solidFill>
-                  <a:srgbClr val="5A7674"/>
+                  <a:srgbClr val="33555F"/>
                 </a:solidFill>
                 <a:latin typeface="Plus Jakarta Sans"/>
               </a:rPr>
@@ -18029,11 +18029,11 @@
             </a:avLst>
           </a:prstGeom>
           <a:solidFill>
-            <a:srgbClr val="F2F8F7"/>
+            <a:srgbClr val="F0F7F8"/>
           </a:solidFill>
           <a:ln w="12700">
             <a:solidFill>
-              <a:srgbClr val="DCEAE8"/>
+              <a:srgbClr val="DCEAED"/>
             </a:solidFill>
           </a:ln>
           <a:effectLst/>
@@ -18093,7 +18093,7 @@
             <a:r>
               <a:rPr sz="1100" b="1">
                 <a:solidFill>
-                  <a:srgbClr val="17302E"/>
+                  <a:srgbClr val="0E2830"/>
                 </a:solidFill>
                 <a:latin typeface="Outfit"/>
               </a:rPr>
@@ -18112,7 +18112,7 @@
             <a:r>
               <a:rPr sz="919" b="0">
                 <a:solidFill>
-                  <a:srgbClr val="5A7674"/>
+                  <a:srgbClr val="33555F"/>
                 </a:solidFill>
                 <a:latin typeface="Plus Jakarta Sans"/>
               </a:rPr>
@@ -18138,11 +18138,11 @@
             </a:avLst>
           </a:prstGeom>
           <a:solidFill>
-            <a:srgbClr val="F2F8F7"/>
+            <a:srgbClr val="F0F7F8"/>
           </a:solidFill>
           <a:ln w="12700">
             <a:solidFill>
-              <a:srgbClr val="DCEAE8"/>
+              <a:srgbClr val="DCEAED"/>
             </a:solidFill>
           </a:ln>
           <a:effectLst/>
@@ -18202,7 +18202,7 @@
             <a:r>
               <a:rPr sz="1100" b="1">
                 <a:solidFill>
-                  <a:srgbClr val="17302E"/>
+                  <a:srgbClr val="0E2830"/>
                 </a:solidFill>
                 <a:latin typeface="Outfit"/>
               </a:rPr>
@@ -18221,7 +18221,7 @@
             <a:r>
               <a:rPr sz="919" b="0">
                 <a:solidFill>
-                  <a:srgbClr val="5A7674"/>
+                  <a:srgbClr val="33555F"/>
                 </a:solidFill>
                 <a:latin typeface="Plus Jakarta Sans"/>
               </a:rPr>
@@ -18247,11 +18247,11 @@
             </a:avLst>
           </a:prstGeom>
           <a:solidFill>
-            <a:srgbClr val="F2F8F7"/>
+            <a:srgbClr val="F0F7F8"/>
           </a:solidFill>
           <a:ln w="12700">
             <a:solidFill>
-              <a:srgbClr val="DCEAE8"/>
+              <a:srgbClr val="DCEAED"/>
             </a:solidFill>
           </a:ln>
           <a:effectLst/>
@@ -18311,7 +18311,7 @@
             <a:r>
               <a:rPr sz="1100" b="1">
                 <a:solidFill>
-                  <a:srgbClr val="17302E"/>
+                  <a:srgbClr val="0E2830"/>
                 </a:solidFill>
                 <a:latin typeface="Outfit"/>
               </a:rPr>
@@ -18330,7 +18330,7 @@
             <a:r>
               <a:rPr sz="919" b="0">
                 <a:solidFill>
-                  <a:srgbClr val="5A7674"/>
+                  <a:srgbClr val="33555F"/>
                 </a:solidFill>
                 <a:latin typeface="Plus Jakarta Sans"/>
               </a:rPr>
@@ -18356,11 +18356,11 @@
             </a:avLst>
           </a:prstGeom>
           <a:solidFill>
-            <a:srgbClr val="F2F8F7"/>
+            <a:srgbClr val="F0F7F8"/>
           </a:solidFill>
           <a:ln w="12700">
             <a:solidFill>
-              <a:srgbClr val="DCEAE8"/>
+              <a:srgbClr val="DCEAED"/>
             </a:solidFill>
           </a:ln>
           <a:effectLst/>
@@ -18420,7 +18420,7 @@
             <a:r>
               <a:rPr sz="1100" b="1">
                 <a:solidFill>
-                  <a:srgbClr val="17302E"/>
+                  <a:srgbClr val="0E2830"/>
                 </a:solidFill>
                 <a:latin typeface="Outfit"/>
               </a:rPr>
@@ -18439,7 +18439,7 @@
             <a:r>
               <a:rPr sz="919" b="0">
                 <a:solidFill>
-                  <a:srgbClr val="5A7674"/>
+                  <a:srgbClr val="33555F"/>
                 </a:solidFill>
                 <a:latin typeface="Plus Jakarta Sans"/>
               </a:rPr>
@@ -18465,11 +18465,11 @@
             </a:avLst>
           </a:prstGeom>
           <a:solidFill>
-            <a:srgbClr val="F2F8F7"/>
+            <a:srgbClr val="F0F7F8"/>
           </a:solidFill>
           <a:ln w="12700">
             <a:solidFill>
-              <a:srgbClr val="DCEAE8"/>
+              <a:srgbClr val="DCEAED"/>
             </a:solidFill>
           </a:ln>
           <a:effectLst/>
@@ -18529,7 +18529,7 @@
             <a:r>
               <a:rPr sz="1100" b="1">
                 <a:solidFill>
-                  <a:srgbClr val="17302E"/>
+                  <a:srgbClr val="0E2830"/>
                 </a:solidFill>
                 <a:latin typeface="Outfit"/>
               </a:rPr>
@@ -18548,7 +18548,7 @@
             <a:r>
               <a:rPr sz="919" b="0">
                 <a:solidFill>
-                  <a:srgbClr val="5A7674"/>
+                  <a:srgbClr val="33555F"/>
                 </a:solidFill>
                 <a:latin typeface="Plus Jakarta Sans"/>
               </a:rPr>
@@ -18574,11 +18574,11 @@
             </a:avLst>
           </a:prstGeom>
           <a:solidFill>
-            <a:srgbClr val="FBDCE6"/>
+            <a:srgbClr val="FCE2F0"/>
           </a:solidFill>
           <a:ln w="12700">
             <a:solidFill>
-              <a:srgbClr val="E85C82"/>
+              <a:srgbClr val="F49CCB"/>
             </a:solidFill>
           </a:ln>
           <a:effectLst/>
@@ -18638,7 +18638,7 @@
             <a:r>
               <a:rPr sz="1000" b="0">
                 <a:solidFill>
-                  <a:srgbClr val="17302E"/>
+                  <a:srgbClr val="0E2830"/>
                 </a:solidFill>
                 <a:latin typeface="Plus Jakarta Sans"/>
               </a:rPr>
@@ -18680,7 +18680,7 @@
             <a:r>
               <a:rPr sz="700" b="0" cap="all" spc="140">
                 <a:solidFill>
-                  <a:srgbClr val="8FA6A4"/>
+                  <a:srgbClr val="52737D"/>
                 </a:solidFill>
                 <a:latin typeface="IBM Plex Mono"/>
               </a:rPr>
@@ -18722,7 +18722,7 @@
             <a:r>
               <a:rPr sz="900" b="0">
                 <a:solidFill>
-                  <a:srgbClr val="8FA6A4"/>
+                  <a:srgbClr val="52737D"/>
                 </a:solidFill>
                 <a:latin typeface="IBM Plex Mono"/>
               </a:rPr>
@@ -18764,7 +18764,7 @@
             <a:avLst/>
           </a:prstGeom>
           <a:solidFill>
-            <a:srgbClr val="FFFFFF"/>
+            <a:srgbClr val="FBFDFE"/>
           </a:solidFill>
           <a:ln>
             <a:noFill/>
@@ -18826,7 +18826,7 @@
             <a:r>
               <a:rPr sz="1000" b="0" cap="all" spc="240">
                 <a:solidFill>
-                  <a:srgbClr val="B55615"/>
+                  <a:srgbClr val="8A6608"/>
                 </a:solidFill>
                 <a:latin typeface="IBM Plex Mono"/>
               </a:rPr>
@@ -18868,7 +18868,7 @@
             <a:r>
               <a:rPr sz="3000" b="1">
                 <a:solidFill>
-                  <a:srgbClr val="17302E"/>
+                  <a:srgbClr val="0E2830"/>
                 </a:solidFill>
                 <a:latin typeface="Outfit"/>
               </a:rPr>
@@ -18910,7 +18910,7 @@
             <a:r>
               <a:rPr sz="1200" b="0">
                 <a:solidFill>
-                  <a:srgbClr val="5A7674"/>
+                  <a:srgbClr val="52737D"/>
                 </a:solidFill>
                 <a:latin typeface="Plus Jakarta Sans"/>
               </a:rPr>
@@ -18936,11 +18936,11 @@
             </a:avLst>
           </a:prstGeom>
           <a:solidFill>
-            <a:srgbClr val="0A4B49"/>
+            <a:srgbClr val="0A5F65"/>
           </a:solidFill>
           <a:ln w="12700">
             <a:solidFill>
-              <a:srgbClr val="0A4B49"/>
+              <a:srgbClr val="0A5F65"/>
             </a:solidFill>
           </a:ln>
           <a:effectLst/>
@@ -19000,7 +19000,7 @@
             <a:r>
               <a:rPr sz="800" b="0" cap="all" spc="180">
                 <a:solidFill>
-                  <a:srgbClr val="9DC4C1"/>
+                  <a:srgbClr val="A9D6D9"/>
                 </a:solidFill>
                 <a:latin typeface="IBM Plex Mono"/>
               </a:rPr>
@@ -19038,7 +19038,7 @@
             <a:r>
               <a:rPr sz="900" b="0">
                 <a:solidFill>
-                  <a:srgbClr val="D3E8E6"/>
+                  <a:srgbClr val="DCF2F3"/>
                 </a:solidFill>
                 <a:latin typeface="Plus Jakarta Sans"/>
               </a:rPr>
@@ -19064,11 +19064,11 @@
             </a:avLst>
           </a:prstGeom>
           <a:solidFill>
-            <a:srgbClr val="13807C"/>
+            <a:srgbClr val="0C7A80"/>
           </a:solidFill>
           <a:ln w="12700">
             <a:solidFill>
-              <a:srgbClr val="13807C"/>
+              <a:srgbClr val="0C7A80"/>
             </a:solidFill>
           </a:ln>
           <a:effectLst/>
@@ -19192,11 +19192,11 @@
             </a:avLst>
           </a:prstGeom>
           <a:solidFill>
-            <a:srgbClr val="0A4B49"/>
+            <a:srgbClr val="0A5F65"/>
           </a:solidFill>
           <a:ln w="12700">
             <a:solidFill>
-              <a:srgbClr val="0A4B49"/>
+              <a:srgbClr val="0A5F65"/>
             </a:solidFill>
           </a:ln>
           <a:effectLst/>
@@ -19256,7 +19256,7 @@
             <a:r>
               <a:rPr sz="800" b="0" cap="all" spc="180">
                 <a:solidFill>
-                  <a:srgbClr val="9DC4C1"/>
+                  <a:srgbClr val="A9D6D9"/>
                 </a:solidFill>
                 <a:latin typeface="IBM Plex Mono"/>
               </a:rPr>
@@ -19294,7 +19294,7 @@
             <a:r>
               <a:rPr sz="900" b="0">
                 <a:solidFill>
-                  <a:srgbClr val="D3E8E6"/>
+                  <a:srgbClr val="DCF2F3"/>
                 </a:solidFill>
                 <a:latin typeface="Plus Jakarta Sans"/>
               </a:rPr>
@@ -19320,11 +19320,11 @@
             </a:avLst>
           </a:prstGeom>
           <a:solidFill>
-            <a:srgbClr val="13807C"/>
+            <a:srgbClr val="0C7A80"/>
           </a:solidFill>
           <a:ln w="12700">
             <a:solidFill>
-              <a:srgbClr val="13807C"/>
+              <a:srgbClr val="0C7A80"/>
             </a:solidFill>
           </a:ln>
           <a:effectLst/>
@@ -19464,7 +19464,7 @@
             <a:r>
               <a:rPr sz="700" b="0" cap="all" spc="140">
                 <a:solidFill>
-                  <a:srgbClr val="8FA6A4"/>
+                  <a:srgbClr val="52737D"/>
                 </a:solidFill>
                 <a:latin typeface="IBM Plex Mono"/>
               </a:rPr>
@@ -19506,7 +19506,7 @@
             <a:r>
               <a:rPr sz="900" b="0">
                 <a:solidFill>
-                  <a:srgbClr val="8FA6A4"/>
+                  <a:srgbClr val="52737D"/>
                 </a:solidFill>
                 <a:latin typeface="IBM Plex Mono"/>
               </a:rPr>
@@ -19548,7 +19548,7 @@
             <a:avLst/>
           </a:prstGeom>
           <a:solidFill>
-            <a:srgbClr val="FFFFFF"/>
+            <a:srgbClr val="FBFDFE"/>
           </a:solidFill>
           <a:ln>
             <a:noFill/>
@@ -19610,7 +19610,7 @@
             <a:r>
               <a:rPr sz="1000" b="0" cap="all" spc="240">
                 <a:solidFill>
-                  <a:srgbClr val="B55615"/>
+                  <a:srgbClr val="8A6608"/>
                 </a:solidFill>
                 <a:latin typeface="IBM Plex Mono"/>
               </a:rPr>
@@ -19652,7 +19652,7 @@
             <a:r>
               <a:rPr sz="2900" b="1">
                 <a:solidFill>
-                  <a:srgbClr val="17302E"/>
+                  <a:srgbClr val="0E2830"/>
                 </a:solidFill>
                 <a:latin typeface="Outfit"/>
               </a:rPr>
@@ -19694,7 +19694,7 @@
             <a:r>
               <a:rPr sz="800" b="0" cap="all" spc="180">
                 <a:solidFill>
-                  <a:srgbClr val="5D7573"/>
+                  <a:srgbClr val="52737D"/>
                 </a:solidFill>
                 <a:latin typeface="IBM Plex Mono"/>
               </a:rPr>
@@ -19718,7 +19718,7 @@
             <a:avLst/>
           </a:prstGeom>
           <a:solidFill>
-            <a:srgbClr val="0E6B68"/>
+            <a:srgbClr val="E9B949"/>
           </a:solidFill>
           <a:ln>
             <a:noFill/>
@@ -19780,7 +19780,7 @@
             <a:r>
               <a:rPr sz="980" b="0">
                 <a:solidFill>
-                  <a:srgbClr val="5A7674"/>
+                  <a:srgbClr val="33555F"/>
                 </a:solidFill>
                 <a:latin typeface="Plus Jakarta Sans"/>
               </a:rPr>
@@ -19804,7 +19804,7 @@
             <a:avLst/>
           </a:prstGeom>
           <a:solidFill>
-            <a:srgbClr val="0E6B68"/>
+            <a:srgbClr val="E9B949"/>
           </a:solidFill>
           <a:ln>
             <a:noFill/>
@@ -19866,7 +19866,7 @@
             <a:r>
               <a:rPr sz="980" b="0">
                 <a:solidFill>
-                  <a:srgbClr val="5A7674"/>
+                  <a:srgbClr val="33555F"/>
                 </a:solidFill>
                 <a:latin typeface="Plus Jakarta Sans"/>
               </a:rPr>
@@ -19890,7 +19890,7 @@
             <a:avLst/>
           </a:prstGeom>
           <a:solidFill>
-            <a:srgbClr val="0E6B68"/>
+            <a:srgbClr val="E9B949"/>
           </a:solidFill>
           <a:ln>
             <a:noFill/>
@@ -19952,7 +19952,7 @@
             <a:r>
               <a:rPr sz="980" b="0">
                 <a:solidFill>
-                  <a:srgbClr val="5A7674"/>
+                  <a:srgbClr val="33555F"/>
                 </a:solidFill>
                 <a:latin typeface="Plus Jakarta Sans"/>
               </a:rPr>
@@ -19976,7 +19976,7 @@
             <a:avLst/>
           </a:prstGeom>
           <a:solidFill>
-            <a:srgbClr val="0E6B68"/>
+            <a:srgbClr val="E9B949"/>
           </a:solidFill>
           <a:ln>
             <a:noFill/>
@@ -20038,7 +20038,7 @@
             <a:r>
               <a:rPr sz="980" b="0">
                 <a:solidFill>
-                  <a:srgbClr val="5A7674"/>
+                  <a:srgbClr val="33555F"/>
                 </a:solidFill>
                 <a:latin typeface="Plus Jakarta Sans"/>
               </a:rPr>
@@ -20064,11 +20064,11 @@
             </a:avLst>
           </a:prstGeom>
           <a:solidFill>
-            <a:srgbClr val="FBDCE6"/>
+            <a:srgbClr val="FCE2F0"/>
           </a:solidFill>
           <a:ln w="12700">
             <a:solidFill>
-              <a:srgbClr val="E85C82"/>
+              <a:srgbClr val="F49CCB"/>
             </a:solidFill>
           </a:ln>
           <a:effectLst/>
@@ -20128,7 +20128,7 @@
             <a:r>
               <a:rPr sz="800" b="0" cap="all" spc="180">
                 <a:solidFill>
-                  <a:srgbClr val="C11B48"/>
+                  <a:srgbClr val="C10073"/>
                 </a:solidFill>
                 <a:latin typeface="IBM Plex Mono"/>
               </a:rPr>
@@ -20147,7 +20147,7 @@
             <a:r>
               <a:rPr sz="1200" b="1">
                 <a:solidFill>
-                  <a:srgbClr val="17302E"/>
+                  <a:srgbClr val="0E2830"/>
                 </a:solidFill>
                 <a:latin typeface="Outfit"/>
               </a:rPr>
@@ -20166,7 +20166,7 @@
             <a:r>
               <a:rPr sz="950" b="1">
                 <a:solidFill>
-                  <a:srgbClr val="17302E"/>
+                  <a:srgbClr val="0E2830"/>
                 </a:solidFill>
                 <a:latin typeface="Plus Jakarta Sans"/>
               </a:rPr>
@@ -20185,7 +20185,7 @@
             <a:r>
               <a:rPr sz="950" b="0">
                 <a:solidFill>
-                  <a:srgbClr val="17302E"/>
+                  <a:srgbClr val="0E2830"/>
                 </a:solidFill>
                 <a:latin typeface="Plus Jakarta Sans"/>
               </a:rPr>
@@ -20204,7 +20204,7 @@
             <a:r>
               <a:rPr sz="950" b="0">
                 <a:solidFill>
-                  <a:srgbClr val="17302E"/>
+                  <a:srgbClr val="0E2830"/>
                 </a:solidFill>
                 <a:latin typeface="Plus Jakarta Sans"/>
               </a:rPr>
@@ -20246,7 +20246,7 @@
             <a:r>
               <a:rPr sz="700" b="0" cap="all" spc="140">
                 <a:solidFill>
-                  <a:srgbClr val="8FA6A4"/>
+                  <a:srgbClr val="52737D"/>
                 </a:solidFill>
                 <a:latin typeface="IBM Plex Mono"/>
               </a:rPr>
@@ -20288,7 +20288,7 @@
             <a:r>
               <a:rPr sz="900" b="0">
                 <a:solidFill>
-                  <a:srgbClr val="8FA6A4"/>
+                  <a:srgbClr val="52737D"/>
                 </a:solidFill>
                 <a:latin typeface="IBM Plex Mono"/>
               </a:rPr>
@@ -20330,7 +20330,7 @@
             <a:avLst/>
           </a:prstGeom>
           <a:solidFill>
-            <a:srgbClr val="FFFFFF"/>
+            <a:srgbClr val="FBFDFE"/>
           </a:solidFill>
           <a:ln>
             <a:noFill/>
@@ -20392,7 +20392,7 @@
             <a:r>
               <a:rPr sz="1000" b="0" cap="all" spc="240">
                 <a:solidFill>
-                  <a:srgbClr val="B55615"/>
+                  <a:srgbClr val="8A6608"/>
                 </a:solidFill>
                 <a:latin typeface="IBM Plex Mono"/>
               </a:rPr>
@@ -20434,7 +20434,7 @@
             <a:r>
               <a:rPr sz="2900" b="1">
                 <a:solidFill>
-                  <a:srgbClr val="17302E"/>
+                  <a:srgbClr val="0E2830"/>
                 </a:solidFill>
                 <a:latin typeface="Outfit"/>
               </a:rPr>
@@ -20476,7 +20476,7 @@
             <a:r>
               <a:rPr sz="1150" b="0">
                 <a:solidFill>
-                  <a:srgbClr val="5A7674"/>
+                  <a:srgbClr val="52737D"/>
                 </a:solidFill>
                 <a:latin typeface="Plus Jakarta Sans"/>
               </a:rPr>
@@ -20502,11 +20502,11 @@
             </a:avLst>
           </a:prstGeom>
           <a:solidFill>
-            <a:srgbClr val="F2F8F7"/>
+            <a:srgbClr val="F0F7F8"/>
           </a:solidFill>
           <a:ln w="12700">
             <a:solidFill>
-              <a:srgbClr val="DCEAE8"/>
+              <a:srgbClr val="DCEAED"/>
             </a:solidFill>
           </a:ln>
           <a:effectLst/>
@@ -20566,7 +20566,7 @@
             <a:r>
               <a:rPr sz="1150" b="1">
                 <a:solidFill>
-                  <a:srgbClr val="17302E"/>
+                  <a:srgbClr val="0E2830"/>
                 </a:solidFill>
                 <a:latin typeface="Outfit"/>
               </a:rPr>
@@ -20585,7 +20585,7 @@
             <a:r>
               <a:rPr sz="950" b="0">
                 <a:solidFill>
-                  <a:srgbClr val="5A7674"/>
+                  <a:srgbClr val="33555F"/>
                 </a:solidFill>
                 <a:latin typeface="Plus Jakarta Sans"/>
               </a:rPr>
@@ -20611,11 +20611,11 @@
             </a:avLst>
           </a:prstGeom>
           <a:solidFill>
-            <a:srgbClr val="F2F8F7"/>
+            <a:srgbClr val="F0F7F8"/>
           </a:solidFill>
           <a:ln w="12700">
             <a:solidFill>
-              <a:srgbClr val="DCEAE8"/>
+              <a:srgbClr val="DCEAED"/>
             </a:solidFill>
           </a:ln>
           <a:effectLst/>
@@ -20675,7 +20675,7 @@
             <a:r>
               <a:rPr sz="1150" b="1">
                 <a:solidFill>
-                  <a:srgbClr val="17302E"/>
+                  <a:srgbClr val="0E2830"/>
                 </a:solidFill>
                 <a:latin typeface="Outfit"/>
               </a:rPr>
@@ -20694,7 +20694,7 @@
             <a:r>
               <a:rPr sz="950" b="0">
                 <a:solidFill>
-                  <a:srgbClr val="5A7674"/>
+                  <a:srgbClr val="33555F"/>
                 </a:solidFill>
                 <a:latin typeface="Plus Jakarta Sans"/>
               </a:rPr>
@@ -20720,11 +20720,11 @@
             </a:avLst>
           </a:prstGeom>
           <a:solidFill>
-            <a:srgbClr val="F2F8F7"/>
+            <a:srgbClr val="F0F7F8"/>
           </a:solidFill>
           <a:ln w="12700">
             <a:solidFill>
-              <a:srgbClr val="DCEAE8"/>
+              <a:srgbClr val="DCEAED"/>
             </a:solidFill>
           </a:ln>
           <a:effectLst/>
@@ -20784,7 +20784,7 @@
             <a:r>
               <a:rPr sz="1150" b="1">
                 <a:solidFill>
-                  <a:srgbClr val="17302E"/>
+                  <a:srgbClr val="0E2830"/>
                 </a:solidFill>
                 <a:latin typeface="Outfit"/>
               </a:rPr>
@@ -20803,7 +20803,7 @@
             <a:r>
               <a:rPr sz="950" b="0">
                 <a:solidFill>
-                  <a:srgbClr val="5A7674"/>
+                  <a:srgbClr val="33555F"/>
                 </a:solidFill>
                 <a:latin typeface="Plus Jakarta Sans"/>
               </a:rPr>
@@ -20829,11 +20829,11 @@
             </a:avLst>
           </a:prstGeom>
           <a:solidFill>
-            <a:srgbClr val="F2F8F7"/>
+            <a:srgbClr val="F0F7F8"/>
           </a:solidFill>
           <a:ln w="12700">
             <a:solidFill>
-              <a:srgbClr val="DCEAE8"/>
+              <a:srgbClr val="DCEAED"/>
             </a:solidFill>
           </a:ln>
           <a:effectLst/>
@@ -20893,7 +20893,7 @@
             <a:r>
               <a:rPr sz="1150" b="1">
                 <a:solidFill>
-                  <a:srgbClr val="17302E"/>
+                  <a:srgbClr val="0E2830"/>
                 </a:solidFill>
                 <a:latin typeface="Outfit"/>
               </a:rPr>
@@ -20912,7 +20912,7 @@
             <a:r>
               <a:rPr sz="950" b="0">
                 <a:solidFill>
-                  <a:srgbClr val="5A7674"/>
+                  <a:srgbClr val="33555F"/>
                 </a:solidFill>
                 <a:latin typeface="Plus Jakarta Sans"/>
               </a:rPr>
@@ -20954,7 +20954,7 @@
             <a:r>
               <a:rPr sz="700" b="0" cap="all" spc="140">
                 <a:solidFill>
-                  <a:srgbClr val="8FA6A4"/>
+                  <a:srgbClr val="52737D"/>
                 </a:solidFill>
                 <a:latin typeface="IBM Plex Mono"/>
               </a:rPr>
@@ -20996,7 +20996,7 @@
             <a:r>
               <a:rPr sz="900" b="0">
                 <a:solidFill>
-                  <a:srgbClr val="8FA6A4"/>
+                  <a:srgbClr val="52737D"/>
                 </a:solidFill>
                 <a:latin typeface="IBM Plex Mono"/>
               </a:rPr>

</xml_diff>